<commit_message>
Flow deck: the four flow pictures are now native PowerPoint shapes (rounded boxes with a bold title and a small description, lines with arrowheads, labels) so the business contact can edit text and move boxes in PowerPoint; no image files in the deck; unused Mermaid sources and PNGs (v2-*, flow-*) removed, the v1 diagrams of the design README stay
Co-Authored-By: Claude Fable 5.1 <noreply@anthropic.com>
Claude-Session: https://claude.ai/code/session_01DA5cmByyXTZsJjuyUviAya
</commit_message>
<xml_diff>
--- a/docs/migration-agent/migration-agent.pptx
+++ b/docs/migration-agent/migration-agent.pptx
@@ -116,7 +116,7 @@
   <p:extLst>
     <p:ext uri="{521415D9-36F7-43E2-AB2F-B90AF26B5E84}">
       <p14:sectionLst xmlns:p14="http://schemas.microsoft.com/office/powerpoint/2010/main">
-        <p14:section name="흐름" id="{e0b87ad3-47a6-8225-2e08-939c9b58b280}">
+        <p14:section name="흐름" id="{71c8b9cf-434f-c343-2bb9-4e7cc2fc1095}">
           <p14:sldIdLst>
             <p14:sldId id="256"/>
             <p14:sldId id="257"/>
@@ -2251,40 +2251,464 @@
           </a:p>
         </p:txBody>
       </p:sp>
-      <p:pic>
-        <p:nvPicPr>
-          <p:cNvPr id="4" name="Image 0" descr="/Users/acandiatale/webWorkspace/migration-agent/docs/migration-agent/diagrams/flow-kb.png">    </p:cNvPr>
-          <p:cNvPicPr>
-            <a:picLocks noChangeAspect="1"/>
-          </p:cNvPicPr>
-          <p:nvPr/>
-        </p:nvPicPr>
-        <p:blipFill>
-          <a:blip r:embed="rId1"/>
-          <a:stretch>
-            <a:fillRect/>
-          </a:stretch>
-        </p:blipFill>
-        <p:spPr>
-          <a:xfrm>
-            <a:off x="457200" y="1132503"/>
-            <a:ext cx="8229600" cy="2078394"/>
-          </a:xfrm>
-          <a:prstGeom prst="rect">
-            <a:avLst/>
-          </a:prstGeom>
-        </p:spPr>
-      </p:pic>
-      <p:sp>
-        <p:nvSpPr>
-          <p:cNvPr id="5" name="Text 1"/>
+      <p:sp>
+        <p:nvSpPr>
+          <p:cNvPr id="4" name="Text 1"/>
+          <p:cNvSpPr/>
+          <p:nvPr/>
+        </p:nvSpPr>
+        <p:spPr>
+          <a:xfrm>
+            <a:off x="457200" y="1005840"/>
+            <a:ext cx="2286000" cy="731520"/>
+          </a:xfrm>
+          <a:prstGeom prst="roundRect">
+            <a:avLst>
+              <a:gd name="adj" fmla="val 6250"/>
+            </a:avLst>
+          </a:prstGeom>
+          <a:solidFill>
+            <a:srgbClr val="EEF3EA"/>
+          </a:solidFill>
+          <a:ln w="12700">
+            <a:solidFill>
+              <a:srgbClr val="2C5F2D"/>
+            </a:solidFill>
+          </a:ln>
+        </p:spPr>
+        <p:txBody>
+          <a:bodyPr wrap="square" lIns="635" tIns="635" rIns="635" bIns="635" rtlCol="0" anchor="ctr"/>
+          <a:lstStyle/>
+          <a:p>
+            <a:pPr algn="ctr" indent="0" marL="0">
+              <a:spcAft>
+                <a:spcPts val="200"/>
+              </a:spcAft>
+              <a:buNone/>
+            </a:pPr>
+            <a:r>
+              <a:rPr lang="en-US" sz="1100" b="1" dirty="0">
+                <a:solidFill>
+                  <a:srgbClr val="1C2A1E"/>
+                </a:solidFill>
+                <a:latin typeface="Calibri" pitchFamily="34" charset="0"/>
+                <a:ea typeface="Calibri" pitchFamily="34" charset="-122"/>
+                <a:cs typeface="Calibri" pitchFamily="34" charset="-120"/>
+              </a:rPr>
+              <a:t>프로젝트 1</a:t>
+            </a:r>
+            <a:endParaRPr lang="en-US" sz="1100" dirty="0"/>
+          </a:p>
+          <a:p>
+            <a:pPr algn="ctr" indent="0" marL="0">
+              <a:spcAft>
+                <a:spcPts val="200"/>
+              </a:spcAft>
+              <a:buNone/>
+            </a:pPr>
+            <a:r>
+              <a:rPr lang="en-US" sz="850" dirty="0">
+                <a:solidFill>
+                  <a:srgbClr val="1C2A1E"/>
+                </a:solidFill>
+                <a:latin typeface="Calibri" pitchFamily="34" charset="0"/>
+                <a:ea typeface="Calibri" pitchFamily="34" charset="-122"/>
+                <a:cs typeface="Calibri" pitchFamily="34" charset="-120"/>
+              </a:rPr>
+              <a:t>처음 보는 오류, LLM 이 고치고 저장</a:t>
+            </a:r>
+            <a:endParaRPr lang="en-US" sz="1100" dirty="0"/>
+          </a:p>
+        </p:txBody>
+      </p:sp>
+      <p:sp>
+        <p:nvSpPr>
+          <p:cNvPr id="5" name="Text 2"/>
+          <p:cNvSpPr/>
+          <p:nvPr/>
+        </p:nvSpPr>
+        <p:spPr>
+          <a:xfrm>
+            <a:off x="457200" y="2377440"/>
+            <a:ext cx="2286000" cy="822960"/>
+          </a:xfrm>
+          <a:prstGeom prst="roundRect">
+            <a:avLst>
+              <a:gd name="adj" fmla="val 5556"/>
+            </a:avLst>
+          </a:prstGeom>
+          <a:solidFill>
+            <a:srgbClr val="3D5A80"/>
+          </a:solidFill>
+          <a:ln w="12700">
+            <a:solidFill>
+              <a:srgbClr val="3D5A80"/>
+            </a:solidFill>
+          </a:ln>
+        </p:spPr>
+        <p:txBody>
+          <a:bodyPr wrap="square" lIns="635" tIns="635" rIns="635" bIns="635" rtlCol="0" anchor="ctr"/>
+          <a:lstStyle/>
+          <a:p>
+            <a:pPr algn="ctr" indent="0" marL="0">
+              <a:spcAft>
+                <a:spcPts val="200"/>
+              </a:spcAft>
+              <a:buNone/>
+            </a:pPr>
+            <a:r>
+              <a:rPr lang="en-US" sz="1100" b="1" dirty="0">
+                <a:solidFill>
+                  <a:srgbClr val="FFFFFF"/>
+                </a:solidFill>
+                <a:latin typeface="Calibri" pitchFamily="34" charset="0"/>
+                <a:ea typeface="Calibri" pitchFamily="34" charset="-122"/>
+                <a:cs typeface="Calibri" pitchFamily="34" charset="-120"/>
+              </a:rPr>
+              <a:t>사람</a:t>
+            </a:r>
+            <a:endParaRPr lang="en-US" sz="1100" dirty="0"/>
+          </a:p>
+          <a:p>
+            <a:pPr algn="ctr" indent="0" marL="0">
+              <a:spcAft>
+                <a:spcPts val="200"/>
+              </a:spcAft>
+              <a:buNone/>
+            </a:pPr>
+            <a:r>
+              <a:rPr lang="en-US" sz="850" dirty="0">
+                <a:solidFill>
+                  <a:srgbClr val="FFFFFF"/>
+                </a:solidFill>
+                <a:latin typeface="Calibri" pitchFamily="34" charset="0"/>
+                <a:ea typeface="Calibri" pitchFamily="34" charset="-122"/>
+                <a:cs typeface="Calibri" pitchFamily="34" charset="-120"/>
+              </a:rPr>
+              <a:t>버전 표를 적어 주거나, 잘못 배운 케이스를 지우거나, 고치지 말라고 표시</a:t>
+            </a:r>
+            <a:endParaRPr lang="en-US" sz="1100" dirty="0"/>
+          </a:p>
+        </p:txBody>
+      </p:sp>
+      <p:sp>
+        <p:nvSpPr>
+          <p:cNvPr id="6" name="Text 3"/>
+          <p:cNvSpPr/>
+          <p:nvPr/>
+        </p:nvSpPr>
+        <p:spPr>
+          <a:xfrm>
+            <a:off x="3291840" y="1600200"/>
+            <a:ext cx="2560320" cy="960120"/>
+          </a:xfrm>
+          <a:prstGeom prst="roundRect">
+            <a:avLst>
+              <a:gd name="adj" fmla="val 4762"/>
+            </a:avLst>
+          </a:prstGeom>
+          <a:solidFill>
+            <a:srgbClr val="2C5F2D"/>
+          </a:solidFill>
+          <a:ln w="12700">
+            <a:solidFill>
+              <a:srgbClr val="2C5F2D"/>
+            </a:solidFill>
+          </a:ln>
+        </p:spPr>
+        <p:txBody>
+          <a:bodyPr wrap="square" lIns="635" tIns="635" rIns="635" bIns="635" rtlCol="0" anchor="ctr"/>
+          <a:lstStyle/>
+          <a:p>
+            <a:pPr algn="ctr" indent="0" marL="0">
+              <a:spcAft>
+                <a:spcPts val="200"/>
+              </a:spcAft>
+              <a:buNone/>
+            </a:pPr>
+            <a:r>
+              <a:rPr lang="en-US" sz="1300" b="1" dirty="0">
+                <a:solidFill>
+                  <a:srgbClr val="FFFFFF"/>
+                </a:solidFill>
+                <a:latin typeface="Calibri" pitchFamily="34" charset="0"/>
+                <a:ea typeface="Calibri" pitchFamily="34" charset="-122"/>
+                <a:cs typeface="Calibri" pitchFamily="34" charset="-120"/>
+              </a:rPr>
+              <a:t>지식베이스</a:t>
+            </a:r>
+            <a:endParaRPr lang="en-US" sz="1300" dirty="0"/>
+          </a:p>
+          <a:p>
+            <a:pPr algn="ctr" indent="0" marL="0">
+              <a:spcAft>
+                <a:spcPts val="200"/>
+              </a:spcAft>
+              <a:buNone/>
+            </a:pPr>
+            <a:r>
+              <a:rPr lang="en-US" sz="900" dirty="0">
+                <a:solidFill>
+                  <a:srgbClr val="FFFFFF"/>
+                </a:solidFill>
+                <a:latin typeface="Calibri" pitchFamily="34" charset="0"/>
+                <a:ea typeface="Calibri" pitchFamily="34" charset="-122"/>
+                <a:cs typeface="Calibri" pitchFamily="34" charset="-120"/>
+              </a:rPr>
+              <a:t>케이스마다 스크립트, 성공·실패 기록, 실패 이유, 고치기 전·후 코드</a:t>
+            </a:r>
+            <a:endParaRPr lang="en-US" sz="1300" dirty="0"/>
+          </a:p>
+        </p:txBody>
+      </p:sp>
+      <p:sp>
+        <p:nvSpPr>
+          <p:cNvPr id="7" name="Text 4"/>
+          <p:cNvSpPr/>
+          <p:nvPr/>
+        </p:nvSpPr>
+        <p:spPr>
+          <a:xfrm>
+            <a:off x="6400800" y="1005840"/>
+            <a:ext cx="2286000" cy="731520"/>
+          </a:xfrm>
+          <a:prstGeom prst="roundRect">
+            <a:avLst>
+              <a:gd name="adj" fmla="val 6250"/>
+            </a:avLst>
+          </a:prstGeom>
+          <a:solidFill>
+            <a:srgbClr val="EEF3EA"/>
+          </a:solidFill>
+          <a:ln w="12700">
+            <a:solidFill>
+              <a:srgbClr val="2C5F2D"/>
+            </a:solidFill>
+          </a:ln>
+        </p:spPr>
+        <p:txBody>
+          <a:bodyPr wrap="square" lIns="635" tIns="635" rIns="635" bIns="635" rtlCol="0" anchor="ctr"/>
+          <a:lstStyle/>
+          <a:p>
+            <a:pPr algn="ctr" indent="0" marL="0">
+              <a:spcAft>
+                <a:spcPts val="200"/>
+              </a:spcAft>
+              <a:buNone/>
+            </a:pPr>
+            <a:r>
+              <a:rPr lang="en-US" sz="1100" b="1" dirty="0">
+                <a:solidFill>
+                  <a:srgbClr val="1C2A1E"/>
+                </a:solidFill>
+                <a:latin typeface="Calibri" pitchFamily="34" charset="0"/>
+                <a:ea typeface="Calibri" pitchFamily="34" charset="-122"/>
+                <a:cs typeface="Calibri" pitchFamily="34" charset="-120"/>
+              </a:rPr>
+              <a:t>프로젝트 2</a:t>
+            </a:r>
+            <a:endParaRPr lang="en-US" sz="1100" dirty="0"/>
+          </a:p>
+          <a:p>
+            <a:pPr algn="ctr" indent="0" marL="0">
+              <a:spcAft>
+                <a:spcPts val="200"/>
+              </a:spcAft>
+              <a:buNone/>
+            </a:pPr>
+            <a:r>
+              <a:rPr lang="en-US" sz="850" dirty="0">
+                <a:solidFill>
+                  <a:srgbClr val="1C2A1E"/>
+                </a:solidFill>
+                <a:latin typeface="Calibri" pitchFamily="34" charset="0"/>
+                <a:ea typeface="Calibri" pitchFamily="34" charset="-122"/>
+                <a:cs typeface="Calibri" pitchFamily="34" charset="-120"/>
+              </a:rPr>
+              <a:t>같은 오류, 저장된 스크립트로 바로 해결</a:t>
+            </a:r>
+            <a:endParaRPr lang="en-US" sz="1100" dirty="0"/>
+          </a:p>
+        </p:txBody>
+      </p:sp>
+      <p:sp>
+        <p:nvSpPr>
+          <p:cNvPr id="8" name="Text 5"/>
+          <p:cNvSpPr/>
+          <p:nvPr/>
+        </p:nvSpPr>
+        <p:spPr>
+          <a:xfrm>
+            <a:off x="6400800" y="2377440"/>
+            <a:ext cx="2286000" cy="822960"/>
+          </a:xfrm>
+          <a:prstGeom prst="roundRect">
+            <a:avLst>
+              <a:gd name="adj" fmla="val 5556"/>
+            </a:avLst>
+          </a:prstGeom>
+          <a:solidFill>
+            <a:srgbClr val="EEF3EA"/>
+          </a:solidFill>
+          <a:ln w="12700">
+            <a:solidFill>
+              <a:srgbClr val="2C5F2D"/>
+            </a:solidFill>
+          </a:ln>
+        </p:spPr>
+        <p:txBody>
+          <a:bodyPr wrap="square" lIns="635" tIns="635" rIns="635" bIns="635" rtlCol="0" anchor="ctr"/>
+          <a:lstStyle/>
+          <a:p>
+            <a:pPr algn="ctr" indent="0" marL="0">
+              <a:spcAft>
+                <a:spcPts val="200"/>
+              </a:spcAft>
+              <a:buNone/>
+            </a:pPr>
+            <a:r>
+              <a:rPr lang="en-US" sz="1100" b="1" dirty="0">
+                <a:solidFill>
+                  <a:srgbClr val="1C2A1E"/>
+                </a:solidFill>
+                <a:latin typeface="Calibri" pitchFamily="34" charset="0"/>
+                <a:ea typeface="Calibri" pitchFamily="34" charset="-122"/>
+                <a:cs typeface="Calibri" pitchFamily="34" charset="-120"/>
+              </a:rPr>
+              <a:t>프로젝트 3 …</a:t>
+            </a:r>
+            <a:endParaRPr lang="en-US" sz="1100" dirty="0"/>
+          </a:p>
+          <a:p>
+            <a:pPr algn="ctr" indent="0" marL="0">
+              <a:spcAft>
+                <a:spcPts val="200"/>
+              </a:spcAft>
+              <a:buNone/>
+            </a:pPr>
+            <a:r>
+              <a:rPr lang="en-US" sz="850" dirty="0">
+                <a:solidFill>
+                  <a:srgbClr val="1C2A1E"/>
+                </a:solidFill>
+                <a:latin typeface="Calibri" pitchFamily="34" charset="0"/>
+                <a:ea typeface="Calibri" pitchFamily="34" charset="-122"/>
+                <a:cs typeface="Calibri" pitchFamily="34" charset="-120"/>
+              </a:rPr>
+              <a:t>안 통하면 보강해서 새 버전으로. 돌수록 LLM 호출이 줄어듭니다</a:t>
+            </a:r>
+            <a:endParaRPr lang="en-US" sz="1100" dirty="0"/>
+          </a:p>
+        </p:txBody>
+      </p:sp>
+      <p:sp>
+        <p:nvSpPr>
+          <p:cNvPr id="9" name="Shape 6"/>
+          <p:cNvSpPr/>
+          <p:nvPr/>
+        </p:nvSpPr>
+        <p:spPr>
+          <a:xfrm>
+            <a:off x="2743200" y="1371600"/>
+            <a:ext cx="548640" cy="525780"/>
+          </a:xfrm>
+          <a:prstGeom prst="line">
+            <a:avLst/>
+          </a:prstGeom>
+          <a:noFill/>
+          <a:ln w="15875">
+            <a:solidFill>
+              <a:srgbClr val="4A4F4A"/>
+            </a:solidFill>
+            <a:prstDash val="solid"/>
+            <a:tailEnd type="triangle"/>
+          </a:ln>
+        </p:spPr>
+      </p:sp>
+      <p:sp>
+        <p:nvSpPr>
+          <p:cNvPr id="10" name="Shape 7"/>
+          <p:cNvSpPr/>
+          <p:nvPr/>
+        </p:nvSpPr>
+        <p:spPr>
+          <a:xfrm flipV="1">
+            <a:off x="2743200" y="2263140"/>
+            <a:ext cx="548640" cy="525780"/>
+          </a:xfrm>
+          <a:prstGeom prst="line">
+            <a:avLst/>
+          </a:prstGeom>
+          <a:noFill/>
+          <a:ln w="15875">
+            <a:solidFill>
+              <a:srgbClr val="4A4F4A"/>
+            </a:solidFill>
+            <a:prstDash val="dash"/>
+            <a:tailEnd type="triangle"/>
+          </a:ln>
+        </p:spPr>
+      </p:sp>
+      <p:sp>
+        <p:nvSpPr>
+          <p:cNvPr id="11" name="Shape 8"/>
+          <p:cNvSpPr/>
+          <p:nvPr/>
+        </p:nvSpPr>
+        <p:spPr>
+          <a:xfrm flipV="1">
+            <a:off x="5852160" y="1371600"/>
+            <a:ext cx="548640" cy="525780"/>
+          </a:xfrm>
+          <a:prstGeom prst="line">
+            <a:avLst/>
+          </a:prstGeom>
+          <a:noFill/>
+          <a:ln w="15875">
+            <a:solidFill>
+              <a:srgbClr val="4A4F4A"/>
+            </a:solidFill>
+            <a:prstDash val="solid"/>
+            <a:headEnd type="triangle"/>
+            <a:tailEnd type="triangle"/>
+          </a:ln>
+        </p:spPr>
+      </p:sp>
+      <p:sp>
+        <p:nvSpPr>
+          <p:cNvPr id="12" name="Shape 9"/>
+          <p:cNvSpPr/>
+          <p:nvPr/>
+        </p:nvSpPr>
+        <p:spPr>
+          <a:xfrm>
+            <a:off x="5852160" y="2263140"/>
+            <a:ext cx="548640" cy="525780"/>
+          </a:xfrm>
+          <a:prstGeom prst="line">
+            <a:avLst/>
+          </a:prstGeom>
+          <a:noFill/>
+          <a:ln w="15875">
+            <a:solidFill>
+              <a:srgbClr val="4A4F4A"/>
+            </a:solidFill>
+            <a:prstDash val="solid"/>
+            <a:headEnd type="triangle"/>
+            <a:tailEnd type="triangle"/>
+          </a:ln>
+        </p:spPr>
+      </p:sp>
+      <p:sp>
+        <p:nvSpPr>
+          <p:cNvPr id="13" name="Text 10"/>
           <p:cNvSpPr txBox="1"/>
           <p:nvPr/>
         </p:nvSpPr>
         <p:spPr>
           <a:xfrm>
-            <a:off x="457200" y="3474720"/>
-            <a:ext cx="8229600" cy="1234440"/>
+            <a:off x="457200" y="3383280"/>
+            <a:ext cx="8229600" cy="1325880"/>
           </a:xfrm>
           <a:prstGeom prst="rect">
             <a:avLst/>
@@ -2304,14 +2728,14 @@
               <a:buChar char="•"/>
             </a:pPr>
             <a:r>
-              <a:rPr lang="en-US" sz="1150" dirty="0">
+              <a:rPr lang="en-US" sz="1100" dirty="0">
                 <a:solidFill>
                   <a:schemeClr val="tx1"/>
                 </a:solidFill>
               </a:rPr>
               <a:t>같은 모양의 오류는 어느 프로젝트에서 나와도 같은 케이스로 모입니다. 케이스마다 수정 스크립트와 성공·실패 횟수, 실패한 이유, 고치기 전·후 코드가 쌓입니다.</a:t>
             </a:r>
-            <a:endParaRPr lang="en-US" sz="1150" dirty="0"/>
+            <a:endParaRPr lang="en-US" sz="1100" dirty="0"/>
           </a:p>
           <a:p>
             <a:pPr marL="342900" indent="-342900">
@@ -2322,14 +2746,14 @@
               <a:buChar char="•"/>
             </a:pPr>
             <a:r>
-              <a:rPr lang="en-US" sz="1150" dirty="0">
+              <a:rPr lang="en-US" sz="1100" dirty="0">
                 <a:solidFill>
                   <a:schemeClr val="tx1"/>
                 </a:solidFill>
               </a:rPr>
               <a:t>프로젝트를 순서대로 돌리면 뒤로 갈수록 LLM 을 덜 부릅니다. 끝나면 보고서 맨 앞에 사람이 확인하거나 이어서 할 일이 적혀 있습니다.</a:t>
             </a:r>
-            <a:endParaRPr lang="en-US" sz="1150" dirty="0"/>
+            <a:endParaRPr lang="en-US" sz="1100" dirty="0"/>
           </a:p>
           <a:p>
             <a:pPr marL="342900" indent="-342900">
@@ -2340,14 +2764,14 @@
               <a:buChar char="•"/>
             </a:pPr>
             <a:r>
-              <a:rPr lang="en-US" sz="1150" dirty="0">
+              <a:rPr lang="en-US" sz="1100" dirty="0">
                 <a:solidFill>
                   <a:schemeClr val="tx1"/>
                 </a:solidFill>
               </a:rPr>
               <a:t>사람이 개입할 수 있습니다: 라이브러리 버전 표를 적어 주기, 잘못 배운 케이스 지우기, 고치지 말라고 표시하기.</a:t>
             </a:r>
-            <a:endParaRPr lang="en-US" sz="1150" dirty="0"/>
+            <a:endParaRPr lang="en-US" sz="1100" dirty="0"/>
           </a:p>
         </p:txBody>
       </p:sp>
@@ -2459,39 +2883,1269 @@
           </a:p>
         </p:txBody>
       </p:sp>
-      <p:pic>
-        <p:nvPicPr>
-          <p:cNvPr id="4" name="Image 0" descr="/Users/acandiatale/webWorkspace/migration-agent/docs/migration-agent/diagrams/flow-overview.png">    </p:cNvPr>
-          <p:cNvPicPr>
-            <a:picLocks noChangeAspect="1"/>
-          </p:cNvPicPr>
-          <p:nvPr/>
-        </p:nvPicPr>
-        <p:blipFill>
-          <a:blip r:embed="rId1"/>
-          <a:stretch>
-            <a:fillRect/>
-          </a:stretch>
-        </p:blipFill>
-        <p:spPr>
-          <a:xfrm>
-            <a:off x="1132867" y="932688"/>
-            <a:ext cx="6878265" cy="3246120"/>
+      <p:sp>
+        <p:nvSpPr>
+          <p:cNvPr id="4" name="Text 1"/>
+          <p:cNvSpPr/>
+          <p:nvPr/>
+        </p:nvSpPr>
+        <p:spPr>
+          <a:xfrm>
+            <a:off x="457200" y="987552"/>
+            <a:ext cx="1828800" cy="713232"/>
+          </a:xfrm>
+          <a:prstGeom prst="roundRect">
+            <a:avLst>
+              <a:gd name="adj" fmla="val 6410"/>
+            </a:avLst>
+          </a:prstGeom>
+          <a:solidFill>
+            <a:srgbClr val="EEF3EA"/>
+          </a:solidFill>
+          <a:ln w="12700">
+            <a:solidFill>
+              <a:srgbClr val="2C5F2D"/>
+            </a:solidFill>
+          </a:ln>
+        </p:spPr>
+        <p:txBody>
+          <a:bodyPr wrap="square" lIns="635" tIns="635" rIns="635" bIns="635" rtlCol="0" anchor="ctr"/>
+          <a:lstStyle/>
+          <a:p>
+            <a:pPr algn="ctr" indent="0" marL="0">
+              <a:spcAft>
+                <a:spcPts val="200"/>
+              </a:spcAft>
+              <a:buNone/>
+            </a:pPr>
+            <a:r>
+              <a:rPr lang="en-US" sz="1100" b="1" dirty="0">
+                <a:solidFill>
+                  <a:srgbClr val="1C2A1E"/>
+                </a:solidFill>
+                <a:latin typeface="Calibri" pitchFamily="34" charset="0"/>
+                <a:ea typeface="Calibri" pitchFamily="34" charset="-122"/>
+                <a:cs typeface="Calibri" pitchFamily="34" charset="-120"/>
+              </a:rPr>
+              <a:t>① 접수</a:t>
+            </a:r>
+            <a:endParaRPr lang="en-US" sz="1100" dirty="0"/>
+          </a:p>
+          <a:p>
+            <a:pPr algn="ctr" indent="0" marL="0">
+              <a:spcAft>
+                <a:spcPts val="200"/>
+              </a:spcAft>
+              <a:buNone/>
+            </a:pPr>
+            <a:r>
+              <a:rPr lang="en-US" sz="850" dirty="0">
+                <a:solidFill>
+                  <a:srgbClr val="1C2A1E"/>
+                </a:solidFill>
+                <a:latin typeface="Calibri" pitchFamily="34" charset="0"/>
+                <a:ea typeface="Calibri" pitchFamily="34" charset="-122"/>
+                <a:cs typeface="Calibri" pitchFamily="34" charset="-120"/>
+              </a:rPr>
+              <a:t>Maven 프로젝트인지 확인하고 작업용 사본을 만듭니다</a:t>
+            </a:r>
+            <a:endParaRPr lang="en-US" sz="1100" dirty="0"/>
+          </a:p>
+        </p:txBody>
+      </p:sp>
+      <p:sp>
+        <p:nvSpPr>
+          <p:cNvPr id="5" name="Text 2"/>
+          <p:cNvSpPr/>
+          <p:nvPr/>
+        </p:nvSpPr>
+        <p:spPr>
+          <a:xfrm>
+            <a:off x="2590495" y="987552"/>
+            <a:ext cx="1828800" cy="713232"/>
+          </a:xfrm>
+          <a:prstGeom prst="roundRect">
+            <a:avLst>
+              <a:gd name="adj" fmla="val 6410"/>
+            </a:avLst>
+          </a:prstGeom>
+          <a:solidFill>
+            <a:srgbClr val="EEF3EA"/>
+          </a:solidFill>
+          <a:ln w="12700">
+            <a:solidFill>
+              <a:srgbClr val="2C5F2D"/>
+            </a:solidFill>
+          </a:ln>
+        </p:spPr>
+        <p:txBody>
+          <a:bodyPr wrap="square" lIns="635" tIns="635" rIns="635" bIns="635" rtlCol="0" anchor="ctr"/>
+          <a:lstStyle/>
+          <a:p>
+            <a:pPr algn="ctr" indent="0" marL="0">
+              <a:spcAft>
+                <a:spcPts val="200"/>
+              </a:spcAft>
+              <a:buNone/>
+            </a:pPr>
+            <a:r>
+              <a:rPr lang="en-US" sz="1100" b="1" dirty="0">
+                <a:solidFill>
+                  <a:srgbClr val="1C2A1E"/>
+                </a:solidFill>
+                <a:latin typeface="Calibri" pitchFamily="34" charset="0"/>
+                <a:ea typeface="Calibri" pitchFamily="34" charset="-122"/>
+                <a:cs typeface="Calibri" pitchFamily="34" charset="-120"/>
+              </a:rPr>
+              <a:t>② 분석</a:t>
+            </a:r>
+            <a:endParaRPr lang="en-US" sz="1100" dirty="0"/>
+          </a:p>
+          <a:p>
+            <a:pPr algn="ctr" indent="0" marL="0">
+              <a:spcAft>
+                <a:spcPts val="200"/>
+              </a:spcAft>
+              <a:buNone/>
+            </a:pPr>
+            <a:r>
+              <a:rPr lang="en-US" sz="850" dirty="0">
+                <a:solidFill>
+                  <a:srgbClr val="1C2A1E"/>
+                </a:solidFill>
+                <a:latin typeface="Calibri" pitchFamily="34" charset="0"/>
+                <a:ea typeface="Calibri" pitchFamily="34" charset="-122"/>
+                <a:cs typeface="Calibri" pitchFamily="34" charset="-120"/>
+              </a:rPr>
+              <a:t>프로젝트 종류와 쓰는 라이브러리를 읽어 둡니다</a:t>
+            </a:r>
+            <a:endParaRPr lang="en-US" sz="1100" dirty="0"/>
+          </a:p>
+        </p:txBody>
+      </p:sp>
+      <p:sp>
+        <p:nvSpPr>
+          <p:cNvPr id="6" name="Text 3"/>
+          <p:cNvSpPr/>
+          <p:nvPr/>
+        </p:nvSpPr>
+        <p:spPr>
+          <a:xfrm>
+            <a:off x="4723790" y="987552"/>
+            <a:ext cx="1828800" cy="713232"/>
+          </a:xfrm>
+          <a:prstGeom prst="roundRect">
+            <a:avLst>
+              <a:gd name="adj" fmla="val 6410"/>
+            </a:avLst>
+          </a:prstGeom>
+          <a:solidFill>
+            <a:srgbClr val="EEF3EA"/>
+          </a:solidFill>
+          <a:ln w="12700">
+            <a:solidFill>
+              <a:srgbClr val="2C5F2D"/>
+            </a:solidFill>
+          </a:ln>
+        </p:spPr>
+        <p:txBody>
+          <a:bodyPr wrap="square" lIns="635" tIns="635" rIns="635" bIns="635" rtlCol="0" anchor="ctr"/>
+          <a:lstStyle/>
+          <a:p>
+            <a:pPr algn="ctr" indent="0" marL="0">
+              <a:spcAft>
+                <a:spcPts val="200"/>
+              </a:spcAft>
+              <a:buNone/>
+            </a:pPr>
+            <a:r>
+              <a:rPr lang="en-US" sz="1100" b="1" dirty="0">
+                <a:solidFill>
+                  <a:srgbClr val="1C2A1E"/>
+                </a:solidFill>
+                <a:latin typeface="Calibri" pitchFamily="34" charset="0"/>
+                <a:ea typeface="Calibri" pitchFamily="34" charset="-122"/>
+                <a:cs typeface="Calibri" pitchFamily="34" charset="-120"/>
+              </a:rPr>
+              <a:t>③ 계획</a:t>
+            </a:r>
+            <a:endParaRPr lang="en-US" sz="1100" dirty="0"/>
+          </a:p>
+          <a:p>
+            <a:pPr algn="ctr" indent="0" marL="0">
+              <a:spcAft>
+                <a:spcPts val="200"/>
+              </a:spcAft>
+              <a:buNone/>
+            </a:pPr>
+            <a:r>
+              <a:rPr lang="en-US" sz="850" dirty="0">
+                <a:solidFill>
+                  <a:srgbClr val="1C2A1E"/>
+                </a:solidFill>
+                <a:latin typeface="Calibri" pitchFamily="34" charset="0"/>
+                <a:ea typeface="Calibri" pitchFamily="34" charset="-122"/>
+                <a:cs typeface="Calibri" pitchFamily="34" charset="-120"/>
+              </a:rPr>
+              <a:t>종류에 맞춰 돌릴 단계와 순서를 정합니다</a:t>
+            </a:r>
+            <a:endParaRPr lang="en-US" sz="1100" dirty="0"/>
+          </a:p>
+        </p:txBody>
+      </p:sp>
+      <p:sp>
+        <p:nvSpPr>
+          <p:cNvPr id="7" name="Text 4"/>
+          <p:cNvSpPr/>
+          <p:nvPr/>
+        </p:nvSpPr>
+        <p:spPr>
+          <a:xfrm>
+            <a:off x="6857086" y="987552"/>
+            <a:ext cx="1828800" cy="713232"/>
+          </a:xfrm>
+          <a:prstGeom prst="roundRect">
+            <a:avLst>
+              <a:gd name="adj" fmla="val 6410"/>
+            </a:avLst>
+          </a:prstGeom>
+          <a:solidFill>
+            <a:srgbClr val="EEF3EA"/>
+          </a:solidFill>
+          <a:ln w="12700">
+            <a:solidFill>
+              <a:srgbClr val="2C5F2D"/>
+            </a:solidFill>
+          </a:ln>
+        </p:spPr>
+        <p:txBody>
+          <a:bodyPr wrap="square" lIns="635" tIns="635" rIns="635" bIns="635" rtlCol="0" anchor="ctr"/>
+          <a:lstStyle/>
+          <a:p>
+            <a:pPr algn="ctr" indent="0" marL="0">
+              <a:spcAft>
+                <a:spcPts val="200"/>
+              </a:spcAft>
+              <a:buNone/>
+            </a:pPr>
+            <a:r>
+              <a:rPr lang="en-US" sz="1100" b="1" dirty="0">
+                <a:solidFill>
+                  <a:srgbClr val="1C2A1E"/>
+                </a:solidFill>
+                <a:latin typeface="Calibri" pitchFamily="34" charset="0"/>
+                <a:ea typeface="Calibri" pitchFamily="34" charset="-122"/>
+                <a:cs typeface="Calibri" pitchFamily="34" charset="-120"/>
+              </a:rPr>
+              <a:t>④ 자동 변환</a:t>
+            </a:r>
+            <a:endParaRPr lang="en-US" sz="1100" dirty="0"/>
+          </a:p>
+          <a:p>
+            <a:pPr algn="ctr" indent="0" marL="0">
+              <a:spcAft>
+                <a:spcPts val="200"/>
+              </a:spcAft>
+              <a:buNone/>
+            </a:pPr>
+            <a:r>
+              <a:rPr lang="en-US" sz="850" dirty="0">
+                <a:solidFill>
+                  <a:srgbClr val="1C2A1E"/>
+                </a:solidFill>
+                <a:latin typeface="Calibri" pitchFamily="34" charset="0"/>
+                <a:ea typeface="Calibri" pitchFamily="34" charset="-122"/>
+                <a:cs typeface="Calibri" pitchFamily="34" charset="-120"/>
+              </a:rPr>
+              <a:t>JDK 21, jakarta, Spring Boot 4 규칙을 한 번에 적용합니다</a:t>
+            </a:r>
+            <a:endParaRPr lang="en-US" sz="1100" dirty="0"/>
+          </a:p>
+        </p:txBody>
+      </p:sp>
+      <p:sp>
+        <p:nvSpPr>
+          <p:cNvPr id="8" name="Text 5"/>
+          <p:cNvSpPr/>
+          <p:nvPr/>
+        </p:nvSpPr>
+        <p:spPr>
+          <a:xfrm>
+            <a:off x="457200" y="1993392"/>
+            <a:ext cx="1828800" cy="713232"/>
+          </a:xfrm>
+          <a:prstGeom prst="roundRect">
+            <a:avLst>
+              <a:gd name="adj" fmla="val 6410"/>
+            </a:avLst>
+          </a:prstGeom>
+          <a:solidFill>
+            <a:srgbClr val="F2CC8F"/>
+          </a:solidFill>
+          <a:ln w="12700">
+            <a:solidFill>
+              <a:srgbClr val="C9A24C"/>
+            </a:solidFill>
+          </a:ln>
+        </p:spPr>
+        <p:txBody>
+          <a:bodyPr wrap="square" lIns="635" tIns="635" rIns="635" bIns="635" rtlCol="0" anchor="ctr"/>
+          <a:lstStyle/>
+          <a:p>
+            <a:pPr algn="ctr" indent="0" marL="0">
+              <a:spcAft>
+                <a:spcPts val="200"/>
+              </a:spcAft>
+              <a:buNone/>
+            </a:pPr>
+            <a:r>
+              <a:rPr lang="en-US" sz="1100" b="1" dirty="0">
+                <a:solidFill>
+                  <a:srgbClr val="1C2A1E"/>
+                </a:solidFill>
+                <a:latin typeface="Calibri" pitchFamily="34" charset="0"/>
+                <a:ea typeface="Calibri" pitchFamily="34" charset="-122"/>
+                <a:cs typeface="Calibri" pitchFamily="34" charset="-120"/>
+              </a:rPr>
+              <a:t>⑤ 1차 컴파일</a:t>
+            </a:r>
+            <a:endParaRPr lang="en-US" sz="1100" dirty="0"/>
+          </a:p>
+          <a:p>
+            <a:pPr algn="ctr" indent="0" marL="0">
+              <a:spcAft>
+                <a:spcPts val="200"/>
+              </a:spcAft>
+              <a:buNone/>
+            </a:pPr>
+            <a:r>
+              <a:rPr lang="en-US" sz="850" dirty="0">
+                <a:solidFill>
+                  <a:srgbClr val="1C2A1E"/>
+                </a:solidFill>
+                <a:latin typeface="Calibri" pitchFamily="34" charset="0"/>
+                <a:ea typeface="Calibri" pitchFamily="34" charset="-122"/>
+                <a:cs typeface="Calibri" pitchFamily="34" charset="-120"/>
+              </a:rPr>
+              <a:t>지금 보이는 오류를 전부 목록에 적어 둡니다</a:t>
+            </a:r>
+            <a:endParaRPr lang="en-US" sz="1100" dirty="0"/>
+          </a:p>
+        </p:txBody>
+      </p:sp>
+      <p:sp>
+        <p:nvSpPr>
+          <p:cNvPr id="9" name="Text 6"/>
+          <p:cNvSpPr/>
+          <p:nvPr/>
+        </p:nvSpPr>
+        <p:spPr>
+          <a:xfrm>
+            <a:off x="2590495" y="1993392"/>
+            <a:ext cx="1828800" cy="713232"/>
+          </a:xfrm>
+          <a:prstGeom prst="roundRect">
+            <a:avLst>
+              <a:gd name="adj" fmla="val 6410"/>
+            </a:avLst>
+          </a:prstGeom>
+          <a:solidFill>
+            <a:srgbClr val="EEF3EA"/>
+          </a:solidFill>
+          <a:ln w="12700">
+            <a:solidFill>
+              <a:srgbClr val="2C5F2D"/>
+            </a:solidFill>
+          </a:ln>
+        </p:spPr>
+        <p:txBody>
+          <a:bodyPr wrap="square" lIns="635" tIns="635" rIns="635" bIns="635" rtlCol="0" anchor="ctr"/>
+          <a:lstStyle/>
+          <a:p>
+            <a:pPr algn="ctr" indent="0" marL="0">
+              <a:spcAft>
+                <a:spcPts val="200"/>
+              </a:spcAft>
+              <a:buNone/>
+            </a:pPr>
+            <a:r>
+              <a:rPr lang="en-US" sz="1100" b="1" dirty="0">
+                <a:solidFill>
+                  <a:srgbClr val="1C2A1E"/>
+                </a:solidFill>
+                <a:latin typeface="Calibri" pitchFamily="34" charset="0"/>
+                <a:ea typeface="Calibri" pitchFamily="34" charset="-122"/>
+                <a:cs typeface="Calibri" pitchFamily="34" charset="-120"/>
+              </a:rPr>
+              <a:t>⑥ 구조 정리</a:t>
+            </a:r>
+            <a:endParaRPr lang="en-US" sz="1100" dirty="0"/>
+          </a:p>
+          <a:p>
+            <a:pPr algn="ctr" indent="0" marL="0">
+              <a:spcAft>
+                <a:spcPts val="200"/>
+              </a:spcAft>
+              <a:buNone/>
+            </a:pPr>
+            <a:r>
+              <a:rPr lang="en-US" sz="850" dirty="0">
+                <a:solidFill>
+                  <a:srgbClr val="1C2A1E"/>
+                </a:solidFill>
+                <a:latin typeface="Calibri" pitchFamily="34" charset="0"/>
+                <a:ea typeface="Calibri" pitchFamily="34" charset="-122"/>
+                <a:cs typeface="Calibri" pitchFamily="34" charset="-120"/>
+              </a:rPr>
+              <a:t>회사 표준 구조로 모듈과 pom.xml 을 다시 짭니다</a:t>
+            </a:r>
+            <a:endParaRPr lang="en-US" sz="1100" dirty="0"/>
+          </a:p>
+        </p:txBody>
+      </p:sp>
+      <p:sp>
+        <p:nvSpPr>
+          <p:cNvPr id="10" name="Text 7"/>
+          <p:cNvSpPr/>
+          <p:nvPr/>
+        </p:nvSpPr>
+        <p:spPr>
+          <a:xfrm>
+            <a:off x="4723790" y="1993392"/>
+            <a:ext cx="1828800" cy="713232"/>
+          </a:xfrm>
+          <a:prstGeom prst="roundRect">
+            <a:avLst>
+              <a:gd name="adj" fmla="val 6410"/>
+            </a:avLst>
+          </a:prstGeom>
+          <a:solidFill>
+            <a:srgbClr val="3D5A80"/>
+          </a:solidFill>
+          <a:ln w="12700">
+            <a:solidFill>
+              <a:srgbClr val="3D5A80"/>
+            </a:solidFill>
+          </a:ln>
+        </p:spPr>
+        <p:txBody>
+          <a:bodyPr wrap="square" lIns="635" tIns="635" rIns="635" bIns="635" rtlCol="0" anchor="ctr"/>
+          <a:lstStyle/>
+          <a:p>
+            <a:pPr algn="ctr" indent="0" marL="0">
+              <a:spcAft>
+                <a:spcPts val="200"/>
+              </a:spcAft>
+              <a:buNone/>
+            </a:pPr>
+            <a:r>
+              <a:rPr lang="en-US" sz="1100" b="1" dirty="0">
+                <a:solidFill>
+                  <a:srgbClr val="FFFFFF"/>
+                </a:solidFill>
+                <a:latin typeface="Calibri" pitchFamily="34" charset="0"/>
+                <a:ea typeface="Calibri" pitchFamily="34" charset="-122"/>
+                <a:cs typeface="Calibri" pitchFamily="34" charset="-120"/>
+              </a:rPr>
+              <a:t>⑦ 구조 검토</a:t>
+            </a:r>
+            <a:endParaRPr lang="en-US" sz="1100" dirty="0"/>
+          </a:p>
+          <a:p>
+            <a:pPr algn="ctr" indent="0" marL="0">
+              <a:spcAft>
+                <a:spcPts val="200"/>
+              </a:spcAft>
+              <a:buNone/>
+            </a:pPr>
+            <a:r>
+              <a:rPr lang="en-US" sz="850" dirty="0">
+                <a:solidFill>
+                  <a:srgbClr val="FFFFFF"/>
+                </a:solidFill>
+                <a:latin typeface="Calibri" pitchFamily="34" charset="0"/>
+                <a:ea typeface="Calibri" pitchFamily="34" charset="-122"/>
+                <a:cs typeface="Calibri" pitchFamily="34" charset="-120"/>
+              </a:rPr>
+              <a:t>LLM 이 회사 규칙에 맞는지 보고 꼭 필요한 것만 고칩니다</a:t>
+            </a:r>
+            <a:endParaRPr lang="en-US" sz="1100" dirty="0"/>
+          </a:p>
+        </p:txBody>
+      </p:sp>
+      <p:sp>
+        <p:nvSpPr>
+          <p:cNvPr id="11" name="Text 8"/>
+          <p:cNvSpPr/>
+          <p:nvPr/>
+        </p:nvSpPr>
+        <p:spPr>
+          <a:xfrm>
+            <a:off x="457200" y="2999232"/>
+            <a:ext cx="1828800" cy="713232"/>
+          </a:xfrm>
+          <a:prstGeom prst="roundRect">
+            <a:avLst>
+              <a:gd name="adj" fmla="val 6410"/>
+            </a:avLst>
+          </a:prstGeom>
+          <a:solidFill>
+            <a:srgbClr val="F2CC8F"/>
+          </a:solidFill>
+          <a:ln w="12700">
+            <a:solidFill>
+              <a:srgbClr val="C9A24C"/>
+            </a:solidFill>
+          </a:ln>
+        </p:spPr>
+        <p:txBody>
+          <a:bodyPr wrap="square" lIns="635" tIns="635" rIns="635" bIns="635" rtlCol="0" anchor="ctr"/>
+          <a:lstStyle/>
+          <a:p>
+            <a:pPr algn="ctr" indent="0" marL="0">
+              <a:spcAft>
+                <a:spcPts val="200"/>
+              </a:spcAft>
+              <a:buNone/>
+            </a:pPr>
+            <a:r>
+              <a:rPr lang="en-US" sz="1100" b="1" dirty="0">
+                <a:solidFill>
+                  <a:srgbClr val="1C2A1E"/>
+                </a:solidFill>
+                <a:latin typeface="Calibri" pitchFamily="34" charset="0"/>
+                <a:ea typeface="Calibri" pitchFamily="34" charset="-122"/>
+                <a:cs typeface="Calibri" pitchFamily="34" charset="-120"/>
+              </a:rPr>
+              <a:t>⑧ 검증 빌드</a:t>
+            </a:r>
+            <a:endParaRPr lang="en-US" sz="1100" dirty="0"/>
+          </a:p>
+          <a:p>
+            <a:pPr algn="ctr" indent="0" marL="0">
+              <a:spcAft>
+                <a:spcPts val="200"/>
+              </a:spcAft>
+              <a:buNone/>
+            </a:pPr>
+            <a:r>
+              <a:rPr lang="en-US" sz="850" dirty="0">
+                <a:solidFill>
+                  <a:srgbClr val="1C2A1E"/>
+                </a:solidFill>
+                <a:latin typeface="Calibri" pitchFamily="34" charset="0"/>
+                <a:ea typeface="Calibri" pitchFamily="34" charset="-122"/>
+                <a:cs typeface="Calibri" pitchFamily="34" charset="-120"/>
+              </a:rPr>
+              <a:t>mvn clean package. 성공이면 바로 마무리로</a:t>
+            </a:r>
+            <a:endParaRPr lang="en-US" sz="1100" dirty="0"/>
+          </a:p>
+        </p:txBody>
+      </p:sp>
+      <p:sp>
+        <p:nvSpPr>
+          <p:cNvPr id="12" name="Text 9"/>
+          <p:cNvSpPr/>
+          <p:nvPr/>
+        </p:nvSpPr>
+        <p:spPr>
+          <a:xfrm>
+            <a:off x="2590495" y="2999232"/>
+            <a:ext cx="1828800" cy="713232"/>
+          </a:xfrm>
+          <a:prstGeom prst="roundRect">
+            <a:avLst>
+              <a:gd name="adj" fmla="val 6410"/>
+            </a:avLst>
+          </a:prstGeom>
+          <a:solidFill>
+            <a:srgbClr val="E07A5F"/>
+          </a:solidFill>
+          <a:ln w="12700">
+            <a:solidFill>
+              <a:srgbClr val="E07A5F"/>
+            </a:solidFill>
+          </a:ln>
+        </p:spPr>
+        <p:txBody>
+          <a:bodyPr wrap="square" lIns="635" tIns="635" rIns="635" bIns="635" rtlCol="0" anchor="ctr"/>
+          <a:lstStyle/>
+          <a:p>
+            <a:pPr algn="ctr" indent="0" marL="0">
+              <a:spcAft>
+                <a:spcPts val="200"/>
+              </a:spcAft>
+              <a:buNone/>
+            </a:pPr>
+            <a:r>
+              <a:rPr lang="en-US" sz="1100" b="1" dirty="0">
+                <a:solidFill>
+                  <a:srgbClr val="FFFFFF"/>
+                </a:solidFill>
+                <a:latin typeface="Calibri" pitchFamily="34" charset="0"/>
+                <a:ea typeface="Calibri" pitchFamily="34" charset="-122"/>
+                <a:cs typeface="Calibri" pitchFamily="34" charset="-120"/>
+              </a:rPr>
+              <a:t>⑨ 수정 루프</a:t>
+            </a:r>
+            <a:endParaRPr lang="en-US" sz="1100" dirty="0"/>
+          </a:p>
+          <a:p>
+            <a:pPr algn="ctr" indent="0" marL="0">
+              <a:spcAft>
+                <a:spcPts val="200"/>
+              </a:spcAft>
+              <a:buNone/>
+            </a:pPr>
+            <a:r>
+              <a:rPr lang="en-US" sz="850" dirty="0">
+                <a:solidFill>
+                  <a:srgbClr val="FFFFFF"/>
+                </a:solidFill>
+                <a:latin typeface="Calibri" pitchFamily="34" charset="0"/>
+                <a:ea typeface="Calibri" pitchFamily="34" charset="-122"/>
+                <a:cs typeface="Calibri" pitchFamily="34" charset="-120"/>
+              </a:rPr>
+              <a:t>오류를 묶어 하나씩 고치고 다시 빌드. 될 때까지 반복</a:t>
+            </a:r>
+            <a:endParaRPr lang="en-US" sz="1100" dirty="0"/>
+          </a:p>
+        </p:txBody>
+      </p:sp>
+      <p:sp>
+        <p:nvSpPr>
+          <p:cNvPr id="13" name="Text 10"/>
+          <p:cNvSpPr/>
+          <p:nvPr/>
+        </p:nvSpPr>
+        <p:spPr>
+          <a:xfrm>
+            <a:off x="4723790" y="2999232"/>
+            <a:ext cx="1828800" cy="713232"/>
+          </a:xfrm>
+          <a:prstGeom prst="roundRect">
+            <a:avLst>
+              <a:gd name="adj" fmla="val 6410"/>
+            </a:avLst>
+          </a:prstGeom>
+          <a:solidFill>
+            <a:srgbClr val="F2CC8F"/>
+          </a:solidFill>
+          <a:ln w="12700">
+            <a:solidFill>
+              <a:srgbClr val="C9A24C"/>
+            </a:solidFill>
+          </a:ln>
+        </p:spPr>
+        <p:txBody>
+          <a:bodyPr wrap="square" lIns="635" tIns="635" rIns="635" bIns="635" rtlCol="0" anchor="ctr"/>
+          <a:lstStyle/>
+          <a:p>
+            <a:pPr algn="ctr" indent="0" marL="0">
+              <a:spcAft>
+                <a:spcPts val="200"/>
+              </a:spcAft>
+              <a:buNone/>
+            </a:pPr>
+            <a:r>
+              <a:rPr lang="en-US" sz="1100" b="1" dirty="0">
+                <a:solidFill>
+                  <a:srgbClr val="1C2A1E"/>
+                </a:solidFill>
+                <a:latin typeface="Calibri" pitchFamily="34" charset="0"/>
+                <a:ea typeface="Calibri" pitchFamily="34" charset="-122"/>
+                <a:cs typeface="Calibri" pitchFamily="34" charset="-120"/>
+              </a:rPr>
+              <a:t>⑩ 최종 빌드</a:t>
+            </a:r>
+            <a:endParaRPr lang="en-US" sz="1100" dirty="0"/>
+          </a:p>
+          <a:p>
+            <a:pPr algn="ctr" indent="0" marL="0">
+              <a:spcAft>
+                <a:spcPts val="200"/>
+              </a:spcAft>
+              <a:buNone/>
+            </a:pPr>
+            <a:r>
+              <a:rPr lang="en-US" sz="850" dirty="0">
+                <a:solidFill>
+                  <a:srgbClr val="1C2A1E"/>
+                </a:solidFill>
+                <a:latin typeface="Calibri" pitchFamily="34" charset="0"/>
+                <a:ea typeface="Calibri" pitchFamily="34" charset="-122"/>
+                <a:cs typeface="Calibri" pitchFamily="34" charset="-120"/>
+              </a:rPr>
+              <a:t>한 번 더 전체 빌드로 결과를 확정합니다</a:t>
+            </a:r>
+            <a:endParaRPr lang="en-US" sz="1100" dirty="0"/>
+          </a:p>
+        </p:txBody>
+      </p:sp>
+      <p:sp>
+        <p:nvSpPr>
+          <p:cNvPr id="14" name="Text 11"/>
+          <p:cNvSpPr/>
+          <p:nvPr/>
+        </p:nvSpPr>
+        <p:spPr>
+          <a:xfrm>
+            <a:off x="6857086" y="2999232"/>
+            <a:ext cx="1828800" cy="713232"/>
+          </a:xfrm>
+          <a:prstGeom prst="roundRect">
+            <a:avLst>
+              <a:gd name="adj" fmla="val 6410"/>
+            </a:avLst>
+          </a:prstGeom>
+          <a:solidFill>
+            <a:srgbClr val="2C5F2D"/>
+          </a:solidFill>
+          <a:ln w="12700">
+            <a:solidFill>
+              <a:srgbClr val="2C5F2D"/>
+            </a:solidFill>
+          </a:ln>
+        </p:spPr>
+        <p:txBody>
+          <a:bodyPr wrap="square" lIns="635" tIns="635" rIns="635" bIns="635" rtlCol="0" anchor="ctr"/>
+          <a:lstStyle/>
+          <a:p>
+            <a:pPr algn="ctr" indent="0" marL="0">
+              <a:spcAft>
+                <a:spcPts val="200"/>
+              </a:spcAft>
+              <a:buNone/>
+            </a:pPr>
+            <a:r>
+              <a:rPr lang="en-US" sz="1100" b="1" dirty="0">
+                <a:solidFill>
+                  <a:srgbClr val="FFFFFF"/>
+                </a:solidFill>
+                <a:latin typeface="Calibri" pitchFamily="34" charset="0"/>
+                <a:ea typeface="Calibri" pitchFamily="34" charset="-122"/>
+                <a:cs typeface="Calibri" pitchFamily="34" charset="-120"/>
+              </a:rPr>
+              <a:t>⑪ 마무리</a:t>
+            </a:r>
+            <a:endParaRPr lang="en-US" sz="1100" dirty="0"/>
+          </a:p>
+          <a:p>
+            <a:pPr algn="ctr" indent="0" marL="0">
+              <a:spcAft>
+                <a:spcPts val="200"/>
+              </a:spcAft>
+              <a:buNone/>
+            </a:pPr>
+            <a:r>
+              <a:rPr lang="en-US" sz="850" dirty="0">
+                <a:solidFill>
+                  <a:srgbClr val="FFFFFF"/>
+                </a:solidFill>
+                <a:latin typeface="Calibri" pitchFamily="34" charset="0"/>
+                <a:ea typeface="Calibri" pitchFamily="34" charset="-122"/>
+                <a:cs typeface="Calibri" pitchFamily="34" charset="-120"/>
+              </a:rPr>
+              <a:t>보고서를 쓰고 수정 방법을 지식베이스에 저장합니다</a:t>
+            </a:r>
+            <a:endParaRPr lang="en-US" sz="1100" dirty="0"/>
+          </a:p>
+        </p:txBody>
+      </p:sp>
+      <p:sp>
+        <p:nvSpPr>
+          <p:cNvPr id="15" name="Shape 12"/>
+          <p:cNvSpPr/>
+          <p:nvPr/>
+        </p:nvSpPr>
+        <p:spPr>
+          <a:xfrm>
+            <a:off x="2286000" y="1344168"/>
+            <a:ext cx="304495" cy="0"/>
+          </a:xfrm>
+          <a:prstGeom prst="line">
+            <a:avLst/>
+          </a:prstGeom>
+          <a:noFill/>
+          <a:ln w="15875">
+            <a:solidFill>
+              <a:srgbClr val="4A4F4A"/>
+            </a:solidFill>
+            <a:prstDash val="solid"/>
+            <a:tailEnd type="triangle"/>
+          </a:ln>
+        </p:spPr>
+      </p:sp>
+      <p:sp>
+        <p:nvSpPr>
+          <p:cNvPr id="16" name="Shape 13"/>
+          <p:cNvSpPr/>
+          <p:nvPr/>
+        </p:nvSpPr>
+        <p:spPr>
+          <a:xfrm>
+            <a:off x="4419295" y="1344168"/>
+            <a:ext cx="304495" cy="0"/>
+          </a:xfrm>
+          <a:prstGeom prst="line">
+            <a:avLst/>
+          </a:prstGeom>
+          <a:noFill/>
+          <a:ln w="15875">
+            <a:solidFill>
+              <a:srgbClr val="4A4F4A"/>
+            </a:solidFill>
+            <a:prstDash val="solid"/>
+            <a:tailEnd type="triangle"/>
+          </a:ln>
+        </p:spPr>
+      </p:sp>
+      <p:sp>
+        <p:nvSpPr>
+          <p:cNvPr id="17" name="Shape 14"/>
+          <p:cNvSpPr/>
+          <p:nvPr/>
+        </p:nvSpPr>
+        <p:spPr>
+          <a:xfrm>
+            <a:off x="6552590" y="1344168"/>
+            <a:ext cx="304495" cy="0"/>
+          </a:xfrm>
+          <a:prstGeom prst="line">
+            <a:avLst/>
+          </a:prstGeom>
+          <a:noFill/>
+          <a:ln w="15875">
+            <a:solidFill>
+              <a:srgbClr val="4A4F4A"/>
+            </a:solidFill>
+            <a:prstDash val="solid"/>
+            <a:tailEnd type="triangle"/>
+          </a:ln>
+        </p:spPr>
+      </p:sp>
+      <p:sp>
+        <p:nvSpPr>
+          <p:cNvPr id="18" name="Shape 15"/>
+          <p:cNvSpPr/>
+          <p:nvPr/>
+        </p:nvSpPr>
+        <p:spPr>
+          <a:xfrm>
+            <a:off x="2286000" y="2350008"/>
+            <a:ext cx="304495" cy="0"/>
+          </a:xfrm>
+          <a:prstGeom prst="line">
+            <a:avLst/>
+          </a:prstGeom>
+          <a:noFill/>
+          <a:ln w="15875">
+            <a:solidFill>
+              <a:srgbClr val="4A4F4A"/>
+            </a:solidFill>
+            <a:prstDash val="solid"/>
+            <a:tailEnd type="triangle"/>
+          </a:ln>
+        </p:spPr>
+      </p:sp>
+      <p:sp>
+        <p:nvSpPr>
+          <p:cNvPr id="19" name="Shape 16"/>
+          <p:cNvSpPr/>
+          <p:nvPr/>
+        </p:nvSpPr>
+        <p:spPr>
+          <a:xfrm>
+            <a:off x="4419295" y="2350008"/>
+            <a:ext cx="304495" cy="0"/>
+          </a:xfrm>
+          <a:prstGeom prst="line">
+            <a:avLst/>
+          </a:prstGeom>
+          <a:noFill/>
+          <a:ln w="15875">
+            <a:solidFill>
+              <a:srgbClr val="4A4F4A"/>
+            </a:solidFill>
+            <a:prstDash val="solid"/>
+            <a:tailEnd type="triangle"/>
+          </a:ln>
+        </p:spPr>
+      </p:sp>
+      <p:sp>
+        <p:nvSpPr>
+          <p:cNvPr id="20" name="Shape 17"/>
+          <p:cNvSpPr/>
+          <p:nvPr/>
+        </p:nvSpPr>
+        <p:spPr>
+          <a:xfrm>
+            <a:off x="4419295" y="3355848"/>
+            <a:ext cx="304495" cy="0"/>
+          </a:xfrm>
+          <a:prstGeom prst="line">
+            <a:avLst/>
+          </a:prstGeom>
+          <a:noFill/>
+          <a:ln w="15875">
+            <a:solidFill>
+              <a:srgbClr val="4A4F4A"/>
+            </a:solidFill>
+            <a:prstDash val="solid"/>
+            <a:tailEnd type="triangle"/>
+          </a:ln>
+        </p:spPr>
+      </p:sp>
+      <p:sp>
+        <p:nvSpPr>
+          <p:cNvPr id="21" name="Shape 18"/>
+          <p:cNvSpPr/>
+          <p:nvPr/>
+        </p:nvSpPr>
+        <p:spPr>
+          <a:xfrm>
+            <a:off x="6552590" y="3355848"/>
+            <a:ext cx="304495" cy="0"/>
+          </a:xfrm>
+          <a:prstGeom prst="line">
+            <a:avLst/>
+          </a:prstGeom>
+          <a:noFill/>
+          <a:ln w="15875">
+            <a:solidFill>
+              <a:srgbClr val="4A4F4A"/>
+            </a:solidFill>
+            <a:prstDash val="solid"/>
+            <a:tailEnd type="triangle"/>
+          </a:ln>
+        </p:spPr>
+      </p:sp>
+      <p:sp>
+        <p:nvSpPr>
+          <p:cNvPr id="22" name="Shape 19"/>
+          <p:cNvSpPr/>
+          <p:nvPr/>
+        </p:nvSpPr>
+        <p:spPr>
+          <a:xfrm>
+            <a:off x="7771486" y="1700784"/>
+            <a:ext cx="0" cy="146304"/>
+          </a:xfrm>
+          <a:prstGeom prst="line">
+            <a:avLst/>
+          </a:prstGeom>
+          <a:noFill/>
+          <a:ln w="15875">
+            <a:solidFill>
+              <a:srgbClr val="4A4F4A"/>
+            </a:solidFill>
+            <a:prstDash val="solid"/>
+          </a:ln>
+        </p:spPr>
+      </p:sp>
+      <p:sp>
+        <p:nvSpPr>
+          <p:cNvPr id="23" name="Shape 20"/>
+          <p:cNvSpPr/>
+          <p:nvPr/>
+        </p:nvSpPr>
+        <p:spPr>
+          <a:xfrm flipH="1">
+            <a:off x="1371600" y="1847088"/>
+            <a:ext cx="6399886" cy="0"/>
+          </a:xfrm>
+          <a:prstGeom prst="line">
+            <a:avLst/>
+          </a:prstGeom>
+          <a:noFill/>
+          <a:ln w="15875">
+            <a:solidFill>
+              <a:srgbClr val="4A4F4A"/>
+            </a:solidFill>
+            <a:prstDash val="solid"/>
+          </a:ln>
+        </p:spPr>
+      </p:sp>
+      <p:sp>
+        <p:nvSpPr>
+          <p:cNvPr id="24" name="Shape 21"/>
+          <p:cNvSpPr/>
+          <p:nvPr/>
+        </p:nvSpPr>
+        <p:spPr>
+          <a:xfrm>
+            <a:off x="1371600" y="1847088"/>
+            <a:ext cx="0" cy="146304"/>
+          </a:xfrm>
+          <a:prstGeom prst="line">
+            <a:avLst/>
+          </a:prstGeom>
+          <a:noFill/>
+          <a:ln w="15875">
+            <a:solidFill>
+              <a:srgbClr val="4A4F4A"/>
+            </a:solidFill>
+            <a:prstDash val="solid"/>
+            <a:tailEnd type="triangle"/>
+          </a:ln>
+        </p:spPr>
+      </p:sp>
+      <p:sp>
+        <p:nvSpPr>
+          <p:cNvPr id="25" name="Shape 22"/>
+          <p:cNvSpPr/>
+          <p:nvPr/>
+        </p:nvSpPr>
+        <p:spPr>
+          <a:xfrm>
+            <a:off x="5638190" y="2706624"/>
+            <a:ext cx="0" cy="146304"/>
+          </a:xfrm>
+          <a:prstGeom prst="line">
+            <a:avLst/>
+          </a:prstGeom>
+          <a:noFill/>
+          <a:ln w="15875">
+            <a:solidFill>
+              <a:srgbClr val="4A4F4A"/>
+            </a:solidFill>
+            <a:prstDash val="solid"/>
+          </a:ln>
+        </p:spPr>
+      </p:sp>
+      <p:sp>
+        <p:nvSpPr>
+          <p:cNvPr id="26" name="Shape 23"/>
+          <p:cNvSpPr/>
+          <p:nvPr/>
+        </p:nvSpPr>
+        <p:spPr>
+          <a:xfrm flipH="1">
+            <a:off x="1371600" y="2852928"/>
+            <a:ext cx="4266590" cy="0"/>
+          </a:xfrm>
+          <a:prstGeom prst="line">
+            <a:avLst/>
+          </a:prstGeom>
+          <a:noFill/>
+          <a:ln w="15875">
+            <a:solidFill>
+              <a:srgbClr val="4A4F4A"/>
+            </a:solidFill>
+            <a:prstDash val="solid"/>
+          </a:ln>
+        </p:spPr>
+      </p:sp>
+      <p:sp>
+        <p:nvSpPr>
+          <p:cNvPr id="27" name="Shape 24"/>
+          <p:cNvSpPr/>
+          <p:nvPr/>
+        </p:nvSpPr>
+        <p:spPr>
+          <a:xfrm>
+            <a:off x="1371600" y="2852928"/>
+            <a:ext cx="0" cy="146304"/>
+          </a:xfrm>
+          <a:prstGeom prst="line">
+            <a:avLst/>
+          </a:prstGeom>
+          <a:noFill/>
+          <a:ln w="15875">
+            <a:solidFill>
+              <a:srgbClr val="4A4F4A"/>
+            </a:solidFill>
+            <a:prstDash val="solid"/>
+            <a:tailEnd type="triangle"/>
+          </a:ln>
+        </p:spPr>
+      </p:sp>
+      <p:sp>
+        <p:nvSpPr>
+          <p:cNvPr id="28" name="Shape 25"/>
+          <p:cNvSpPr/>
+          <p:nvPr/>
+        </p:nvSpPr>
+        <p:spPr>
+          <a:xfrm>
+            <a:off x="2286000" y="3355848"/>
+            <a:ext cx="304495" cy="0"/>
+          </a:xfrm>
+          <a:prstGeom prst="line">
+            <a:avLst/>
+          </a:prstGeom>
+          <a:noFill/>
+          <a:ln w="15875">
+            <a:solidFill>
+              <a:srgbClr val="4A4F4A"/>
+            </a:solidFill>
+            <a:prstDash val="solid"/>
+            <a:tailEnd type="triangle"/>
+          </a:ln>
+        </p:spPr>
+      </p:sp>
+      <p:sp>
+        <p:nvSpPr>
+          <p:cNvPr id="29" name="Text 26"/>
+          <p:cNvSpPr txBox="1"/>
+          <p:nvPr/>
+        </p:nvSpPr>
+        <p:spPr>
+          <a:xfrm>
+            <a:off x="2209648" y="3072384"/>
+            <a:ext cx="457200" cy="201168"/>
           </a:xfrm>
           <a:prstGeom prst="rect">
             <a:avLst/>
           </a:prstGeom>
-        </p:spPr>
-      </p:pic>
-      <p:sp>
-        <p:nvSpPr>
-          <p:cNvPr id="5" name="Shape 1"/>
-          <p:cNvSpPr/>
-          <p:nvPr/>
-        </p:nvSpPr>
-        <p:spPr>
-          <a:xfrm>
-            <a:off x="457200" y="4270248"/>
+          <a:solidFill>
+            <a:srgbClr val="FFFFFF"/>
+          </a:solidFill>
+          <a:ln/>
+        </p:spPr>
+        <p:txBody>
+          <a:bodyPr wrap="square" lIns="0" tIns="0" rIns="0" bIns="0" rtlCol="0" anchor="ctr"/>
+          <a:lstStyle/>
+          <a:p>
+            <a:pPr algn="ctr" indent="0" marL="0">
+              <a:buNone/>
+            </a:pPr>
+            <a:r>
+              <a:rPr lang="en-US" sz="850" dirty="0">
+                <a:solidFill>
+                  <a:srgbClr val="4A4F4A"/>
+                </a:solidFill>
+                <a:latin typeface="Calibri" pitchFamily="34" charset="0"/>
+                <a:ea typeface="Calibri" pitchFamily="34" charset="-122"/>
+                <a:cs typeface="Calibri" pitchFamily="34" charset="-120"/>
+              </a:rPr>
+              <a:t>실패</a:t>
+            </a:r>
+            <a:endParaRPr lang="en-US" sz="850" dirty="0"/>
+          </a:p>
+        </p:txBody>
+      </p:sp>
+      <p:sp>
+        <p:nvSpPr>
+          <p:cNvPr id="30" name="Shape 27"/>
+          <p:cNvSpPr/>
+          <p:nvPr/>
+        </p:nvSpPr>
+        <p:spPr>
+          <a:xfrm>
+            <a:off x="1828800" y="3712464"/>
+            <a:ext cx="0" cy="201168"/>
+          </a:xfrm>
+          <a:prstGeom prst="line">
+            <a:avLst/>
+          </a:prstGeom>
+          <a:noFill/>
+          <a:ln w="15875">
+            <a:solidFill>
+              <a:srgbClr val="4A4F4A"/>
+            </a:solidFill>
+            <a:prstDash val="solid"/>
+          </a:ln>
+        </p:spPr>
+      </p:sp>
+      <p:sp>
+        <p:nvSpPr>
+          <p:cNvPr id="31" name="Shape 28"/>
+          <p:cNvSpPr/>
+          <p:nvPr/>
+        </p:nvSpPr>
+        <p:spPr>
+          <a:xfrm>
+            <a:off x="1828800" y="3913632"/>
+            <a:ext cx="5942686" cy="0"/>
+          </a:xfrm>
+          <a:prstGeom prst="line">
+            <a:avLst/>
+          </a:prstGeom>
+          <a:noFill/>
+          <a:ln w="15875">
+            <a:solidFill>
+              <a:srgbClr val="4A4F4A"/>
+            </a:solidFill>
+            <a:prstDash val="solid"/>
+          </a:ln>
+        </p:spPr>
+      </p:sp>
+      <p:sp>
+        <p:nvSpPr>
+          <p:cNvPr id="32" name="Shape 29"/>
+          <p:cNvSpPr/>
+          <p:nvPr/>
+        </p:nvSpPr>
+        <p:spPr>
+          <a:xfrm flipV="1">
+            <a:off x="7771486" y="3712464"/>
+            <a:ext cx="0" cy="201168"/>
+          </a:xfrm>
+          <a:prstGeom prst="line">
+            <a:avLst/>
+          </a:prstGeom>
+          <a:noFill/>
+          <a:ln w="15875">
+            <a:solidFill>
+              <a:srgbClr val="4A4F4A"/>
+            </a:solidFill>
+            <a:prstDash val="solid"/>
+            <a:tailEnd type="triangle"/>
+          </a:ln>
+        </p:spPr>
+      </p:sp>
+      <p:sp>
+        <p:nvSpPr>
+          <p:cNvPr id="33" name="Text 30"/>
+          <p:cNvSpPr txBox="1"/>
+          <p:nvPr/>
+        </p:nvSpPr>
+        <p:spPr>
+          <a:xfrm>
+            <a:off x="4342943" y="3813048"/>
+            <a:ext cx="457200" cy="201168"/>
+          </a:xfrm>
+          <a:prstGeom prst="rect">
+            <a:avLst/>
+          </a:prstGeom>
+          <a:solidFill>
+            <a:srgbClr val="FFFFFF"/>
+          </a:solidFill>
+          <a:ln/>
+        </p:spPr>
+        <p:txBody>
+          <a:bodyPr wrap="square" lIns="0" tIns="0" rIns="0" bIns="0" rtlCol="0" anchor="ctr"/>
+          <a:lstStyle/>
+          <a:p>
+            <a:pPr algn="ctr" indent="0" marL="0">
+              <a:buNone/>
+            </a:pPr>
+            <a:r>
+              <a:rPr lang="en-US" sz="850" dirty="0">
+                <a:solidFill>
+                  <a:srgbClr val="4A4F4A"/>
+                </a:solidFill>
+                <a:latin typeface="Calibri" pitchFamily="34" charset="0"/>
+                <a:ea typeface="Calibri" pitchFamily="34" charset="-122"/>
+                <a:cs typeface="Calibri" pitchFamily="34" charset="-120"/>
+              </a:rPr>
+              <a:t>성공</a:t>
+            </a:r>
+            <a:endParaRPr lang="en-US" sz="850" dirty="0"/>
+          </a:p>
+        </p:txBody>
+      </p:sp>
+      <p:sp>
+        <p:nvSpPr>
+          <p:cNvPr id="34" name="Shape 31"/>
+          <p:cNvSpPr/>
+          <p:nvPr/>
+        </p:nvSpPr>
+        <p:spPr>
+          <a:xfrm>
+            <a:off x="457200" y="4206240"/>
             <a:ext cx="201168" cy="164592"/>
           </a:xfrm>
           <a:prstGeom prst="rect">
@@ -2510,13 +4164,13 @@
       </p:sp>
       <p:sp>
         <p:nvSpPr>
-          <p:cNvPr id="6" name="Text 2"/>
+          <p:cNvPr id="35" name="Text 32"/>
           <p:cNvSpPr txBox="1"/>
           <p:nvPr/>
         </p:nvSpPr>
         <p:spPr>
           <a:xfrm>
-            <a:off x="704088" y="4224528"/>
+            <a:off x="704088" y="4160520"/>
             <a:ext cx="1463040" cy="256032"/>
           </a:xfrm>
           <a:prstGeom prst="rect">
@@ -2546,13 +4200,13 @@
       </p:sp>
       <p:sp>
         <p:nvSpPr>
-          <p:cNvPr id="7" name="Shape 3"/>
-          <p:cNvSpPr/>
-          <p:nvPr/>
-        </p:nvSpPr>
-        <p:spPr>
-          <a:xfrm>
-            <a:off x="2148840" y="4270248"/>
+          <p:cNvPr id="36" name="Shape 33"/>
+          <p:cNvSpPr/>
+          <p:nvPr/>
+        </p:nvSpPr>
+        <p:spPr>
+          <a:xfrm>
+            <a:off x="2148840" y="4206240"/>
             <a:ext cx="201168" cy="164592"/>
           </a:xfrm>
           <a:prstGeom prst="rect">
@@ -2571,13 +4225,13 @@
       </p:sp>
       <p:sp>
         <p:nvSpPr>
-          <p:cNvPr id="8" name="Text 4"/>
+          <p:cNvPr id="37" name="Text 34"/>
           <p:cNvSpPr txBox="1"/>
           <p:nvPr/>
         </p:nvSpPr>
         <p:spPr>
           <a:xfrm>
-            <a:off x="2395728" y="4224528"/>
+            <a:off x="2395728" y="4160520"/>
             <a:ext cx="1463040" cy="256032"/>
           </a:xfrm>
           <a:prstGeom prst="rect">
@@ -2607,13 +4261,13 @@
       </p:sp>
       <p:sp>
         <p:nvSpPr>
-          <p:cNvPr id="9" name="Shape 5"/>
-          <p:cNvSpPr/>
-          <p:nvPr/>
-        </p:nvSpPr>
-        <p:spPr>
-          <a:xfrm>
-            <a:off x="3840480" y="4270248"/>
+          <p:cNvPr id="38" name="Shape 35"/>
+          <p:cNvSpPr/>
+          <p:nvPr/>
+        </p:nvSpPr>
+        <p:spPr>
+          <a:xfrm>
+            <a:off x="3840480" y="4206240"/>
             <a:ext cx="201168" cy="164592"/>
           </a:xfrm>
           <a:prstGeom prst="rect">
@@ -2632,13 +4286,13 @@
       </p:sp>
       <p:sp>
         <p:nvSpPr>
-          <p:cNvPr id="10" name="Text 6"/>
+          <p:cNvPr id="39" name="Text 36"/>
           <p:cNvSpPr txBox="1"/>
           <p:nvPr/>
         </p:nvSpPr>
         <p:spPr>
           <a:xfrm>
-            <a:off x="4087368" y="4224528"/>
+            <a:off x="4087368" y="4160520"/>
             <a:ext cx="1463040" cy="256032"/>
           </a:xfrm>
           <a:prstGeom prst="rect">
@@ -2668,13 +4322,13 @@
       </p:sp>
       <p:sp>
         <p:nvSpPr>
-          <p:cNvPr id="11" name="Shape 7"/>
-          <p:cNvSpPr/>
-          <p:nvPr/>
-        </p:nvSpPr>
-        <p:spPr>
-          <a:xfrm>
-            <a:off x="5532120" y="4270248"/>
+          <p:cNvPr id="40" name="Shape 37"/>
+          <p:cNvSpPr/>
+          <p:nvPr/>
+        </p:nvSpPr>
+        <p:spPr>
+          <a:xfrm>
+            <a:off x="5532120" y="4206240"/>
             <a:ext cx="201168" cy="164592"/>
           </a:xfrm>
           <a:prstGeom prst="rect">
@@ -2693,13 +4347,13 @@
       </p:sp>
       <p:sp>
         <p:nvSpPr>
-          <p:cNvPr id="12" name="Text 8"/>
+          <p:cNvPr id="41" name="Text 38"/>
           <p:cNvSpPr txBox="1"/>
           <p:nvPr/>
         </p:nvSpPr>
         <p:spPr>
           <a:xfrm>
-            <a:off x="5779008" y="4224528"/>
+            <a:off x="5779008" y="4160520"/>
             <a:ext cx="1463040" cy="256032"/>
           </a:xfrm>
           <a:prstGeom prst="rect">
@@ -2729,13 +4383,13 @@
       </p:sp>
       <p:sp>
         <p:nvSpPr>
-          <p:cNvPr id="13" name="Shape 9"/>
-          <p:cNvSpPr/>
-          <p:nvPr/>
-        </p:nvSpPr>
-        <p:spPr>
-          <a:xfrm>
-            <a:off x="7223760" y="4270248"/>
+          <p:cNvPr id="42" name="Shape 39"/>
+          <p:cNvSpPr/>
+          <p:nvPr/>
+        </p:nvSpPr>
+        <p:spPr>
+          <a:xfrm>
+            <a:off x="7223760" y="4206240"/>
             <a:ext cx="201168" cy="164592"/>
           </a:xfrm>
           <a:prstGeom prst="rect">
@@ -2754,13 +4408,13 @@
       </p:sp>
       <p:sp>
         <p:nvSpPr>
-          <p:cNvPr id="14" name="Text 10"/>
+          <p:cNvPr id="43" name="Text 40"/>
           <p:cNvSpPr txBox="1"/>
           <p:nvPr/>
         </p:nvSpPr>
         <p:spPr>
           <a:xfrm>
-            <a:off x="7470648" y="4224528"/>
+            <a:off x="7470648" y="4160520"/>
             <a:ext cx="1463040" cy="256032"/>
           </a:xfrm>
           <a:prstGeom prst="rect">
@@ -2790,13 +4444,13 @@
       </p:sp>
       <p:sp>
         <p:nvSpPr>
-          <p:cNvPr id="15" name="Text 11"/>
+          <p:cNvPr id="44" name="Text 41"/>
           <p:cNvSpPr txBox="1"/>
           <p:nvPr/>
         </p:nvSpPr>
         <p:spPr>
           <a:xfrm>
-            <a:off x="457200" y="4498848"/>
+            <a:off x="457200" y="4462272"/>
             <a:ext cx="8229600" cy="274320"/>
           </a:xfrm>
           <a:prstGeom prst="rect">
@@ -4532,33 +6186,877 @@
           </a:p>
         </p:txBody>
       </p:sp>
-      <p:pic>
-        <p:nvPicPr>
-          <p:cNvPr id="4" name="Image 0" descr="/Users/acandiatale/webWorkspace/migration-agent/docs/migration-agent/diagrams/flow-loop.png">    </p:cNvPr>
-          <p:cNvPicPr>
-            <a:picLocks noChangeAspect="1"/>
-          </p:cNvPicPr>
-          <p:nvPr/>
-        </p:nvPicPr>
-        <p:blipFill>
-          <a:blip r:embed="rId1"/>
-          <a:stretch>
-            <a:fillRect/>
-          </a:stretch>
-        </p:blipFill>
-        <p:spPr>
-          <a:xfrm>
-            <a:off x="457200" y="1367168"/>
-            <a:ext cx="8229600" cy="1700504"/>
+      <p:sp>
+        <p:nvSpPr>
+          <p:cNvPr id="4" name="Text 1"/>
+          <p:cNvSpPr/>
+          <p:nvPr/>
+        </p:nvSpPr>
+        <p:spPr>
+          <a:xfrm>
+            <a:off x="457200" y="1325880"/>
+            <a:ext cx="1463040" cy="777240"/>
+          </a:xfrm>
+          <a:prstGeom prst="roundRect">
+            <a:avLst>
+              <a:gd name="adj" fmla="val 5882"/>
+            </a:avLst>
+          </a:prstGeom>
+          <a:solidFill>
+            <a:srgbClr val="F2CC8F"/>
+          </a:solidFill>
+          <a:ln w="12700">
+            <a:solidFill>
+              <a:srgbClr val="C9A24C"/>
+            </a:solidFill>
+          </a:ln>
+        </p:spPr>
+        <p:txBody>
+          <a:bodyPr wrap="square" lIns="635" tIns="635" rIns="635" bIns="635" rtlCol="0" anchor="ctr"/>
+          <a:lstStyle/>
+          <a:p>
+            <a:pPr algn="ctr" indent="0" marL="0">
+              <a:spcAft>
+                <a:spcPts val="200"/>
+              </a:spcAft>
+              <a:buNone/>
+            </a:pPr>
+            <a:r>
+              <a:rPr lang="en-US" sz="1100" b="1" dirty="0">
+                <a:solidFill>
+                  <a:srgbClr val="1C2A1E"/>
+                </a:solidFill>
+                <a:latin typeface="Calibri" pitchFamily="34" charset="0"/>
+                <a:ea typeface="Calibri" pitchFamily="34" charset="-122"/>
+                <a:cs typeface="Calibri" pitchFamily="34" charset="-120"/>
+              </a:rPr>
+              <a:t>빌드</a:t>
+            </a:r>
+            <a:endParaRPr lang="en-US" sz="1100" dirty="0"/>
+          </a:p>
+          <a:p>
+            <a:pPr algn="ctr" indent="0" marL="0">
+              <a:spcAft>
+                <a:spcPts val="200"/>
+              </a:spcAft>
+              <a:buNone/>
+            </a:pPr>
+            <a:r>
+              <a:rPr lang="en-US" sz="850" dirty="0">
+                <a:solidFill>
+                  <a:srgbClr val="1C2A1E"/>
+                </a:solidFill>
+                <a:latin typeface="Calibri" pitchFamily="34" charset="0"/>
+                <a:ea typeface="Calibri" pitchFamily="34" charset="-122"/>
+                <a:cs typeface="Calibri" pitchFamily="34" charset="-120"/>
+              </a:rPr>
+              <a:t>남은 오류를 봅니다</a:t>
+            </a:r>
+            <a:endParaRPr lang="en-US" sz="1100" dirty="0"/>
+          </a:p>
+        </p:txBody>
+      </p:sp>
+      <p:sp>
+        <p:nvSpPr>
+          <p:cNvPr id="5" name="Text 2"/>
+          <p:cNvSpPr/>
+          <p:nvPr/>
+        </p:nvSpPr>
+        <p:spPr>
+          <a:xfrm>
+            <a:off x="2148840" y="1325880"/>
+            <a:ext cx="1463040" cy="777240"/>
+          </a:xfrm>
+          <a:prstGeom prst="roundRect">
+            <a:avLst>
+              <a:gd name="adj" fmla="val 5882"/>
+            </a:avLst>
+          </a:prstGeom>
+          <a:solidFill>
+            <a:srgbClr val="EEF3EA"/>
+          </a:solidFill>
+          <a:ln w="12700">
+            <a:solidFill>
+              <a:srgbClr val="2C5F2D"/>
+            </a:solidFill>
+          </a:ln>
+        </p:spPr>
+        <p:txBody>
+          <a:bodyPr wrap="square" lIns="635" tIns="635" rIns="635" bIns="635" rtlCol="0" anchor="ctr"/>
+          <a:lstStyle/>
+          <a:p>
+            <a:pPr algn="ctr" indent="0" marL="0">
+              <a:spcAft>
+                <a:spcPts val="200"/>
+              </a:spcAft>
+              <a:buNone/>
+            </a:pPr>
+            <a:r>
+              <a:rPr lang="en-US" sz="1100" b="1" dirty="0">
+                <a:solidFill>
+                  <a:srgbClr val="1C2A1E"/>
+                </a:solidFill>
+                <a:latin typeface="Calibri" pitchFamily="34" charset="0"/>
+                <a:ea typeface="Calibri" pitchFamily="34" charset="-122"/>
+                <a:cs typeface="Calibri" pitchFamily="34" charset="-120"/>
+              </a:rPr>
+              <a:t>채점</a:t>
+            </a:r>
+            <a:endParaRPr lang="en-US" sz="1100" dirty="0"/>
+          </a:p>
+          <a:p>
+            <a:pPr algn="ctr" indent="0" marL="0">
+              <a:spcAft>
+                <a:spcPts val="200"/>
+              </a:spcAft>
+              <a:buNone/>
+            </a:pPr>
+            <a:r>
+              <a:rPr lang="en-US" sz="850" dirty="0">
+                <a:solidFill>
+                  <a:srgbClr val="1C2A1E"/>
+                </a:solidFill>
+                <a:latin typeface="Calibri" pitchFamily="34" charset="0"/>
+                <a:ea typeface="Calibri" pitchFamily="34" charset="-122"/>
+                <a:cs typeface="Calibri" pitchFamily="34" charset="-120"/>
+              </a:rPr>
+              <a:t>직전 수정이 효과 있었나? 나빠졌으면 되돌림</a:t>
+            </a:r>
+            <a:endParaRPr lang="en-US" sz="1100" dirty="0"/>
+          </a:p>
+        </p:txBody>
+      </p:sp>
+      <p:sp>
+        <p:nvSpPr>
+          <p:cNvPr id="6" name="Text 3"/>
+          <p:cNvSpPr/>
+          <p:nvPr/>
+        </p:nvSpPr>
+        <p:spPr>
+          <a:xfrm>
+            <a:off x="3840480" y="1325880"/>
+            <a:ext cx="1463040" cy="777240"/>
+          </a:xfrm>
+          <a:prstGeom prst="roundRect">
+            <a:avLst>
+              <a:gd name="adj" fmla="val 5882"/>
+            </a:avLst>
+          </a:prstGeom>
+          <a:solidFill>
+            <a:srgbClr val="EEF3EA"/>
+          </a:solidFill>
+          <a:ln w="12700">
+            <a:solidFill>
+              <a:srgbClr val="2C5F2D"/>
+            </a:solidFill>
+          </a:ln>
+        </p:spPr>
+        <p:txBody>
+          <a:bodyPr wrap="square" lIns="635" tIns="635" rIns="635" bIns="635" rtlCol="0" anchor="ctr"/>
+          <a:lstStyle/>
+          <a:p>
+            <a:pPr algn="ctr" indent="0" marL="0">
+              <a:spcAft>
+                <a:spcPts val="200"/>
+              </a:spcAft>
+              <a:buNone/>
+            </a:pPr>
+            <a:r>
+              <a:rPr lang="en-US" sz="1100" b="1" dirty="0">
+                <a:solidFill>
+                  <a:srgbClr val="1C2A1E"/>
+                </a:solidFill>
+                <a:latin typeface="Calibri" pitchFamily="34" charset="0"/>
+                <a:ea typeface="Calibri" pitchFamily="34" charset="-122"/>
+                <a:cs typeface="Calibri" pitchFamily="34" charset="-120"/>
+              </a:rPr>
+              <a:t>오류 묶기</a:t>
+            </a:r>
+            <a:endParaRPr lang="en-US" sz="1100" dirty="0"/>
+          </a:p>
+          <a:p>
+            <a:pPr algn="ctr" indent="0" marL="0">
+              <a:spcAft>
+                <a:spcPts val="200"/>
+              </a:spcAft>
+              <a:buNone/>
+            </a:pPr>
+            <a:r>
+              <a:rPr lang="en-US" sz="850" dirty="0">
+                <a:solidFill>
+                  <a:srgbClr val="1C2A1E"/>
+                </a:solidFill>
+                <a:latin typeface="Calibri" pitchFamily="34" charset="0"/>
+                <a:ea typeface="Calibri" pitchFamily="34" charset="-122"/>
+                <a:cs typeface="Calibri" pitchFamily="34" charset="-120"/>
+              </a:rPr>
+              <a:t>같은 원인끼리 케이스로, 근본 원인부터</a:t>
+            </a:r>
+            <a:endParaRPr lang="en-US" sz="1100" dirty="0"/>
+          </a:p>
+        </p:txBody>
+      </p:sp>
+      <p:sp>
+        <p:nvSpPr>
+          <p:cNvPr id="7" name="Text 4"/>
+          <p:cNvSpPr/>
+          <p:nvPr/>
+        </p:nvSpPr>
+        <p:spPr>
+          <a:xfrm>
+            <a:off x="5532120" y="1325880"/>
+            <a:ext cx="1463040" cy="777240"/>
+          </a:xfrm>
+          <a:prstGeom prst="roundRect">
+            <a:avLst>
+              <a:gd name="adj" fmla="val 5882"/>
+            </a:avLst>
+          </a:prstGeom>
+          <a:solidFill>
+            <a:srgbClr val="FFFFFF"/>
+          </a:solidFill>
+          <a:ln w="12700">
+            <a:solidFill>
+              <a:srgbClr val="8A8F8A"/>
+            </a:solidFill>
+          </a:ln>
+        </p:spPr>
+        <p:txBody>
+          <a:bodyPr wrap="square" lIns="635" tIns="635" rIns="635" bIns="635" rtlCol="0" anchor="ctr"/>
+          <a:lstStyle/>
+          <a:p>
+            <a:pPr algn="ctr" indent="0" marL="0">
+              <a:spcAft>
+                <a:spcPts val="200"/>
+              </a:spcAft>
+              <a:buNone/>
+            </a:pPr>
+            <a:r>
+              <a:rPr lang="en-US" sz="1100" b="1" dirty="0">
+                <a:solidFill>
+                  <a:srgbClr val="1C2A1E"/>
+                </a:solidFill>
+                <a:latin typeface="Calibri" pitchFamily="34" charset="0"/>
+                <a:ea typeface="Calibri" pitchFamily="34" charset="-122"/>
+                <a:cs typeface="Calibri" pitchFamily="34" charset="-120"/>
+              </a:rPr>
+              <a:t>방금 손댄 파일?</a:t>
+            </a:r>
+            <a:endParaRPr lang="en-US" sz="1100" dirty="0"/>
+          </a:p>
+          <a:p>
+            <a:pPr algn="ctr" indent="0" marL="0">
+              <a:spcAft>
+                <a:spcPts val="200"/>
+              </a:spcAft>
+              <a:buNone/>
+            </a:pPr>
+            <a:r>
+              <a:rPr lang="en-US" sz="850" dirty="0">
+                <a:solidFill>
+                  <a:srgbClr val="1C2A1E"/>
+                </a:solidFill>
+                <a:latin typeface="Calibri" pitchFamily="34" charset="0"/>
+                <a:ea typeface="Calibri" pitchFamily="34" charset="-122"/>
+                <a:cs typeface="Calibri" pitchFamily="34" charset="-120"/>
+              </a:rPr>
+              <a:t>그러면 다음 빌드까지 보류</a:t>
+            </a:r>
+            <a:endParaRPr lang="en-US" sz="1100" dirty="0"/>
+          </a:p>
+        </p:txBody>
+      </p:sp>
+      <p:sp>
+        <p:nvSpPr>
+          <p:cNvPr id="8" name="Text 5"/>
+          <p:cNvSpPr/>
+          <p:nvPr/>
+        </p:nvSpPr>
+        <p:spPr>
+          <a:xfrm>
+            <a:off x="7223760" y="1325880"/>
+            <a:ext cx="1463040" cy="777240"/>
+          </a:xfrm>
+          <a:prstGeom prst="roundRect">
+            <a:avLst>
+              <a:gd name="adj" fmla="val 5882"/>
+            </a:avLst>
+          </a:prstGeom>
+          <a:solidFill>
+            <a:srgbClr val="E07A5F"/>
+          </a:solidFill>
+          <a:ln w="12700">
+            <a:solidFill>
+              <a:srgbClr val="E07A5F"/>
+            </a:solidFill>
+          </a:ln>
+        </p:spPr>
+        <p:txBody>
+          <a:bodyPr wrap="square" lIns="635" tIns="635" rIns="635" bIns="635" rtlCol="0" anchor="ctr"/>
+          <a:lstStyle/>
+          <a:p>
+            <a:pPr algn="ctr" indent="0" marL="0">
+              <a:spcAft>
+                <a:spcPts val="200"/>
+              </a:spcAft>
+              <a:buNone/>
+            </a:pPr>
+            <a:r>
+              <a:rPr lang="en-US" sz="1100" b="1" dirty="0">
+                <a:solidFill>
+                  <a:srgbClr val="FFFFFF"/>
+                </a:solidFill>
+                <a:latin typeface="Calibri" pitchFamily="34" charset="0"/>
+                <a:ea typeface="Calibri" pitchFamily="34" charset="-122"/>
+                <a:cs typeface="Calibri" pitchFamily="34" charset="-120"/>
+              </a:rPr>
+              <a:t>고치기</a:t>
+            </a:r>
+            <a:endParaRPr lang="en-US" sz="1100" dirty="0"/>
+          </a:p>
+          <a:p>
+            <a:pPr algn="ctr" indent="0" marL="0">
+              <a:spcAft>
+                <a:spcPts val="200"/>
+              </a:spcAft>
+              <a:buNone/>
+            </a:pPr>
+            <a:r>
+              <a:rPr lang="en-US" sz="850" dirty="0">
+                <a:solidFill>
+                  <a:srgbClr val="FFFFFF"/>
+                </a:solidFill>
+                <a:latin typeface="Calibri" pitchFamily="34" charset="0"/>
+                <a:ea typeface="Calibri" pitchFamily="34" charset="-122"/>
+                <a:cs typeface="Calibri" pitchFamily="34" charset="-120"/>
+              </a:rPr>
+              <a:t>저장된 방법 먼저, 없으면 LLM 에게 요청</a:t>
+            </a:r>
+            <a:endParaRPr lang="en-US" sz="1100" dirty="0"/>
+          </a:p>
+        </p:txBody>
+      </p:sp>
+      <p:sp>
+        <p:nvSpPr>
+          <p:cNvPr id="9" name="Text 6"/>
+          <p:cNvSpPr/>
+          <p:nvPr/>
+        </p:nvSpPr>
+        <p:spPr>
+          <a:xfrm>
+            <a:off x="457200" y="2468880"/>
+            <a:ext cx="1463040" cy="777240"/>
+          </a:xfrm>
+          <a:prstGeom prst="roundRect">
+            <a:avLst>
+              <a:gd name="adj" fmla="val 5882"/>
+            </a:avLst>
+          </a:prstGeom>
+          <a:solidFill>
+            <a:srgbClr val="2C5F2D"/>
+          </a:solidFill>
+          <a:ln w="12700">
+            <a:solidFill>
+              <a:srgbClr val="2C5F2D"/>
+            </a:solidFill>
+          </a:ln>
+        </p:spPr>
+        <p:txBody>
+          <a:bodyPr wrap="square" lIns="635" tIns="635" rIns="635" bIns="635" rtlCol="0" anchor="ctr"/>
+          <a:lstStyle/>
+          <a:p>
+            <a:pPr algn="ctr" indent="0" marL="0">
+              <a:spcAft>
+                <a:spcPts val="200"/>
+              </a:spcAft>
+              <a:buNone/>
+            </a:pPr>
+            <a:r>
+              <a:rPr lang="en-US" sz="1100" b="1" dirty="0">
+                <a:solidFill>
+                  <a:srgbClr val="FFFFFF"/>
+                </a:solidFill>
+                <a:latin typeface="Calibri" pitchFamily="34" charset="0"/>
+                <a:ea typeface="Calibri" pitchFamily="34" charset="-122"/>
+                <a:cs typeface="Calibri" pitchFamily="34" charset="-120"/>
+              </a:rPr>
+              <a:t>최종 빌드로</a:t>
+            </a:r>
+            <a:endParaRPr lang="en-US" sz="1100" dirty="0"/>
+          </a:p>
+          <a:p>
+            <a:pPr algn="ctr" indent="0" marL="0">
+              <a:spcAft>
+                <a:spcPts val="200"/>
+              </a:spcAft>
+              <a:buNone/>
+            </a:pPr>
+            <a:r>
+              <a:rPr lang="en-US" sz="850" dirty="0">
+                <a:solidFill>
+                  <a:srgbClr val="FFFFFF"/>
+                </a:solidFill>
+                <a:latin typeface="Calibri" pitchFamily="34" charset="0"/>
+                <a:ea typeface="Calibri" pitchFamily="34" charset="-122"/>
+                <a:cs typeface="Calibri" pitchFamily="34" charset="-120"/>
+              </a:rPr>
+              <a:t>더 고칠 것이 없습니다</a:t>
+            </a:r>
+            <a:endParaRPr lang="en-US" sz="1100" dirty="0"/>
+          </a:p>
+        </p:txBody>
+      </p:sp>
+      <p:sp>
+        <p:nvSpPr>
+          <p:cNvPr id="10" name="Text 7"/>
+          <p:cNvSpPr/>
+          <p:nvPr/>
+        </p:nvSpPr>
+        <p:spPr>
+          <a:xfrm>
+            <a:off x="5532120" y="2468880"/>
+            <a:ext cx="1463040" cy="777240"/>
+          </a:xfrm>
+          <a:prstGeom prst="roundRect">
+            <a:avLst>
+              <a:gd name="adj" fmla="val 5882"/>
+            </a:avLst>
+          </a:prstGeom>
+          <a:solidFill>
+            <a:srgbClr val="EEF3EA"/>
+          </a:solidFill>
+          <a:ln w="12700">
+            <a:solidFill>
+              <a:srgbClr val="2C5F2D"/>
+            </a:solidFill>
+          </a:ln>
+        </p:spPr>
+        <p:txBody>
+          <a:bodyPr wrap="square" lIns="635" tIns="635" rIns="635" bIns="635" rtlCol="0" anchor="ctr"/>
+          <a:lstStyle/>
+          <a:p>
+            <a:pPr algn="ctr" indent="0" marL="0">
+              <a:spcAft>
+                <a:spcPts val="200"/>
+              </a:spcAft>
+              <a:buNone/>
+            </a:pPr>
+            <a:r>
+              <a:rPr lang="en-US" sz="1100" b="1" dirty="0">
+                <a:solidFill>
+                  <a:srgbClr val="1C2A1E"/>
+                </a:solidFill>
+                <a:latin typeface="Calibri" pitchFamily="34" charset="0"/>
+                <a:ea typeface="Calibri" pitchFamily="34" charset="-122"/>
+                <a:cs typeface="Calibri" pitchFamily="34" charset="-120"/>
+              </a:rPr>
+              <a:t>보류</a:t>
+            </a:r>
+            <a:endParaRPr lang="en-US" sz="1100" dirty="0"/>
+          </a:p>
+          <a:p>
+            <a:pPr algn="ctr" indent="0" marL="0">
+              <a:spcAft>
+                <a:spcPts val="200"/>
+              </a:spcAft>
+              <a:buNone/>
+            </a:pPr>
+            <a:r>
+              <a:rPr lang="en-US" sz="850" dirty="0">
+                <a:solidFill>
+                  <a:srgbClr val="1C2A1E"/>
+                </a:solidFill>
+                <a:latin typeface="Calibri" pitchFamily="34" charset="0"/>
+                <a:ea typeface="Calibri" pitchFamily="34" charset="-122"/>
+                <a:cs typeface="Calibri" pitchFamily="34" charset="-120"/>
+              </a:rPr>
+              <a:t>다음 빌드 뒤에 다시 봅니다</a:t>
+            </a:r>
+            <a:endParaRPr lang="en-US" sz="1100" dirty="0"/>
+          </a:p>
+        </p:txBody>
+      </p:sp>
+      <p:sp>
+        <p:nvSpPr>
+          <p:cNvPr id="11" name="Shape 8"/>
+          <p:cNvSpPr/>
+          <p:nvPr/>
+        </p:nvSpPr>
+        <p:spPr>
+          <a:xfrm>
+            <a:off x="1920240" y="1714500"/>
+            <a:ext cx="228600" cy="0"/>
+          </a:xfrm>
+          <a:prstGeom prst="line">
+            <a:avLst/>
+          </a:prstGeom>
+          <a:noFill/>
+          <a:ln w="15875">
+            <a:solidFill>
+              <a:srgbClr val="4A4F4A"/>
+            </a:solidFill>
+            <a:prstDash val="solid"/>
+            <a:tailEnd type="triangle"/>
+          </a:ln>
+        </p:spPr>
+      </p:sp>
+      <p:sp>
+        <p:nvSpPr>
+          <p:cNvPr id="12" name="Shape 9"/>
+          <p:cNvSpPr/>
+          <p:nvPr/>
+        </p:nvSpPr>
+        <p:spPr>
+          <a:xfrm>
+            <a:off x="3611880" y="1714500"/>
+            <a:ext cx="228600" cy="0"/>
+          </a:xfrm>
+          <a:prstGeom prst="line">
+            <a:avLst/>
+          </a:prstGeom>
+          <a:noFill/>
+          <a:ln w="15875">
+            <a:solidFill>
+              <a:srgbClr val="4A4F4A"/>
+            </a:solidFill>
+            <a:prstDash val="solid"/>
+            <a:tailEnd type="triangle"/>
+          </a:ln>
+        </p:spPr>
+      </p:sp>
+      <p:sp>
+        <p:nvSpPr>
+          <p:cNvPr id="13" name="Shape 10"/>
+          <p:cNvSpPr/>
+          <p:nvPr/>
+        </p:nvSpPr>
+        <p:spPr>
+          <a:xfrm>
+            <a:off x="5303520" y="1714500"/>
+            <a:ext cx="228600" cy="0"/>
+          </a:xfrm>
+          <a:prstGeom prst="line">
+            <a:avLst/>
+          </a:prstGeom>
+          <a:noFill/>
+          <a:ln w="15875">
+            <a:solidFill>
+              <a:srgbClr val="4A4F4A"/>
+            </a:solidFill>
+            <a:prstDash val="solid"/>
+            <a:tailEnd type="triangle"/>
+          </a:ln>
+        </p:spPr>
+      </p:sp>
+      <p:sp>
+        <p:nvSpPr>
+          <p:cNvPr id="14" name="Shape 11"/>
+          <p:cNvSpPr/>
+          <p:nvPr/>
+        </p:nvSpPr>
+        <p:spPr>
+          <a:xfrm>
+            <a:off x="6995160" y="1714500"/>
+            <a:ext cx="228600" cy="0"/>
+          </a:xfrm>
+          <a:prstGeom prst="line">
+            <a:avLst/>
+          </a:prstGeom>
+          <a:noFill/>
+          <a:ln w="15875">
+            <a:solidFill>
+              <a:srgbClr val="4A4F4A"/>
+            </a:solidFill>
+            <a:prstDash val="solid"/>
+            <a:tailEnd type="triangle"/>
+          </a:ln>
+        </p:spPr>
+      </p:sp>
+      <p:sp>
+        <p:nvSpPr>
+          <p:cNvPr id="15" name="Text 12"/>
+          <p:cNvSpPr txBox="1"/>
+          <p:nvPr/>
+        </p:nvSpPr>
+        <p:spPr>
+          <a:xfrm>
+            <a:off x="6880860" y="1431036"/>
+            <a:ext cx="457200" cy="201168"/>
           </a:xfrm>
           <a:prstGeom prst="rect">
             <a:avLst/>
           </a:prstGeom>
-        </p:spPr>
-      </p:pic>
-      <p:sp>
-        <p:nvSpPr>
-          <p:cNvPr id="5" name="Text 1"/>
+          <a:solidFill>
+            <a:srgbClr val="FFFFFF"/>
+          </a:solidFill>
+          <a:ln/>
+        </p:spPr>
+        <p:txBody>
+          <a:bodyPr wrap="square" lIns="0" tIns="0" rIns="0" bIns="0" rtlCol="0" anchor="ctr"/>
+          <a:lstStyle/>
+          <a:p>
+            <a:pPr algn="ctr" indent="0" marL="0">
+              <a:buNone/>
+            </a:pPr>
+            <a:r>
+              <a:rPr lang="en-US" sz="850" dirty="0">
+                <a:solidFill>
+                  <a:srgbClr val="4A4F4A"/>
+                </a:solidFill>
+                <a:latin typeface="Calibri" pitchFamily="34" charset="0"/>
+                <a:ea typeface="Calibri" pitchFamily="34" charset="-122"/>
+                <a:cs typeface="Calibri" pitchFamily="34" charset="-120"/>
+              </a:rPr>
+              <a:t>아니오</a:t>
+            </a:r>
+            <a:endParaRPr lang="en-US" sz="850" dirty="0"/>
+          </a:p>
+        </p:txBody>
+      </p:sp>
+      <p:sp>
+        <p:nvSpPr>
+          <p:cNvPr id="16" name="Shape 13"/>
+          <p:cNvSpPr/>
+          <p:nvPr/>
+        </p:nvSpPr>
+        <p:spPr>
+          <a:xfrm>
+            <a:off x="6263640" y="2103120"/>
+            <a:ext cx="0" cy="365760"/>
+          </a:xfrm>
+          <a:prstGeom prst="line">
+            <a:avLst/>
+          </a:prstGeom>
+          <a:noFill/>
+          <a:ln w="15875">
+            <a:solidFill>
+              <a:srgbClr val="4A4F4A"/>
+            </a:solidFill>
+            <a:prstDash val="solid"/>
+            <a:tailEnd type="triangle"/>
+          </a:ln>
+        </p:spPr>
+      </p:sp>
+      <p:sp>
+        <p:nvSpPr>
+          <p:cNvPr id="17" name="Text 14"/>
+          <p:cNvSpPr txBox="1"/>
+          <p:nvPr/>
+        </p:nvSpPr>
+        <p:spPr>
+          <a:xfrm>
+            <a:off x="6355080" y="2185416"/>
+            <a:ext cx="274320" cy="201168"/>
+          </a:xfrm>
+          <a:prstGeom prst="rect">
+            <a:avLst/>
+          </a:prstGeom>
+          <a:solidFill>
+            <a:srgbClr val="FFFFFF"/>
+          </a:solidFill>
+          <a:ln/>
+        </p:spPr>
+        <p:txBody>
+          <a:bodyPr wrap="square" lIns="0" tIns="0" rIns="0" bIns="0" rtlCol="0" anchor="ctr"/>
+          <a:lstStyle/>
+          <a:p>
+            <a:pPr algn="ctr" indent="0" marL="0">
+              <a:buNone/>
+            </a:pPr>
+            <a:r>
+              <a:rPr lang="en-US" sz="850" dirty="0">
+                <a:solidFill>
+                  <a:srgbClr val="4A4F4A"/>
+                </a:solidFill>
+                <a:latin typeface="Calibri" pitchFamily="34" charset="0"/>
+                <a:ea typeface="Calibri" pitchFamily="34" charset="-122"/>
+                <a:cs typeface="Calibri" pitchFamily="34" charset="-120"/>
+              </a:rPr>
+              <a:t>예</a:t>
+            </a:r>
+            <a:endParaRPr lang="en-US" sz="850" dirty="0"/>
+          </a:p>
+        </p:txBody>
+      </p:sp>
+      <p:sp>
+        <p:nvSpPr>
+          <p:cNvPr id="18" name="Shape 15"/>
+          <p:cNvSpPr/>
+          <p:nvPr/>
+        </p:nvSpPr>
+        <p:spPr>
+          <a:xfrm>
+            <a:off x="1188720" y="2103120"/>
+            <a:ext cx="0" cy="365760"/>
+          </a:xfrm>
+          <a:prstGeom prst="line">
+            <a:avLst/>
+          </a:prstGeom>
+          <a:noFill/>
+          <a:ln w="15875">
+            <a:solidFill>
+              <a:srgbClr val="4A4F4A"/>
+            </a:solidFill>
+            <a:prstDash val="solid"/>
+            <a:tailEnd type="triangle"/>
+          </a:ln>
+        </p:spPr>
+      </p:sp>
+      <p:sp>
+        <p:nvSpPr>
+          <p:cNvPr id="19" name="Text 16"/>
+          <p:cNvSpPr txBox="1"/>
+          <p:nvPr/>
+        </p:nvSpPr>
+        <p:spPr>
+          <a:xfrm>
+            <a:off x="1280160" y="2185416"/>
+            <a:ext cx="640080" cy="201168"/>
+          </a:xfrm>
+          <a:prstGeom prst="rect">
+            <a:avLst/>
+          </a:prstGeom>
+          <a:solidFill>
+            <a:srgbClr val="FFFFFF"/>
+          </a:solidFill>
+          <a:ln/>
+        </p:spPr>
+        <p:txBody>
+          <a:bodyPr wrap="square" lIns="0" tIns="0" rIns="0" bIns="0" rtlCol="0" anchor="ctr"/>
+          <a:lstStyle/>
+          <a:p>
+            <a:pPr algn="ctr" indent="0" marL="0">
+              <a:buNone/>
+            </a:pPr>
+            <a:r>
+              <a:rPr lang="en-US" sz="850" dirty="0">
+                <a:solidFill>
+                  <a:srgbClr val="4A4F4A"/>
+                </a:solidFill>
+                <a:latin typeface="Calibri" pitchFamily="34" charset="0"/>
+                <a:ea typeface="Calibri" pitchFamily="34" charset="-122"/>
+                <a:cs typeface="Calibri" pitchFamily="34" charset="-120"/>
+              </a:rPr>
+              <a:t>빌드 성공</a:t>
+            </a:r>
+            <a:endParaRPr lang="en-US" sz="850" dirty="0"/>
+          </a:p>
+        </p:txBody>
+      </p:sp>
+      <p:sp>
+        <p:nvSpPr>
+          <p:cNvPr id="20" name="Shape 17"/>
+          <p:cNvSpPr/>
+          <p:nvPr/>
+        </p:nvSpPr>
+        <p:spPr>
+          <a:xfrm flipV="1">
+            <a:off x="7955280" y="1097280"/>
+            <a:ext cx="0" cy="228600"/>
+          </a:xfrm>
+          <a:prstGeom prst="line">
+            <a:avLst/>
+          </a:prstGeom>
+          <a:noFill/>
+          <a:ln w="15875">
+            <a:solidFill>
+              <a:srgbClr val="4A4F4A"/>
+            </a:solidFill>
+            <a:prstDash val="solid"/>
+          </a:ln>
+        </p:spPr>
+      </p:sp>
+      <p:sp>
+        <p:nvSpPr>
+          <p:cNvPr id="21" name="Shape 18"/>
+          <p:cNvSpPr/>
+          <p:nvPr/>
+        </p:nvSpPr>
+        <p:spPr>
+          <a:xfrm flipH="1">
+            <a:off x="1188720" y="1097280"/>
+            <a:ext cx="6766560" cy="0"/>
+          </a:xfrm>
+          <a:prstGeom prst="line">
+            <a:avLst/>
+          </a:prstGeom>
+          <a:noFill/>
+          <a:ln w="15875">
+            <a:solidFill>
+              <a:srgbClr val="4A4F4A"/>
+            </a:solidFill>
+            <a:prstDash val="solid"/>
+          </a:ln>
+        </p:spPr>
+      </p:sp>
+      <p:sp>
+        <p:nvSpPr>
+          <p:cNvPr id="22" name="Shape 19"/>
+          <p:cNvSpPr/>
+          <p:nvPr/>
+        </p:nvSpPr>
+        <p:spPr>
+          <a:xfrm>
+            <a:off x="1188720" y="1097280"/>
+            <a:ext cx="0" cy="228600"/>
+          </a:xfrm>
+          <a:prstGeom prst="line">
+            <a:avLst/>
+          </a:prstGeom>
+          <a:noFill/>
+          <a:ln w="15875">
+            <a:solidFill>
+              <a:srgbClr val="4A4F4A"/>
+            </a:solidFill>
+            <a:prstDash val="solid"/>
+            <a:tailEnd type="triangle"/>
+          </a:ln>
+        </p:spPr>
+      </p:sp>
+      <p:sp>
+        <p:nvSpPr>
+          <p:cNvPr id="23" name="Text 20"/>
+          <p:cNvSpPr txBox="1"/>
+          <p:nvPr/>
+        </p:nvSpPr>
+        <p:spPr>
+          <a:xfrm>
+            <a:off x="3886200" y="996696"/>
+            <a:ext cx="1371600" cy="201168"/>
+          </a:xfrm>
+          <a:prstGeom prst="rect">
+            <a:avLst/>
+          </a:prstGeom>
+          <a:solidFill>
+            <a:srgbClr val="FFFFFF"/>
+          </a:solidFill>
+          <a:ln/>
+        </p:spPr>
+        <p:txBody>
+          <a:bodyPr wrap="square" lIns="0" tIns="0" rIns="0" bIns="0" rtlCol="0" anchor="ctr"/>
+          <a:lstStyle/>
+          <a:p>
+            <a:pPr algn="ctr" indent="0" marL="0">
+              <a:buNone/>
+            </a:pPr>
+            <a:r>
+              <a:rPr lang="en-US" sz="850" dirty="0">
+                <a:solidFill>
+                  <a:srgbClr val="4A4F4A"/>
+                </a:solidFill>
+                <a:latin typeface="Calibri" pitchFamily="34" charset="0"/>
+                <a:ea typeface="Calibri" pitchFamily="34" charset="-122"/>
+                <a:cs typeface="Calibri" pitchFamily="34" charset="-120"/>
+              </a:rPr>
+              <a:t>다음 바퀴, 최대 50번</a:t>
+            </a:r>
+            <a:endParaRPr lang="en-US" sz="850" dirty="0"/>
+          </a:p>
+        </p:txBody>
+      </p:sp>
+      <p:sp>
+        <p:nvSpPr>
+          <p:cNvPr id="24" name="Text 21"/>
           <p:cNvSpPr txBox="1"/>
           <p:nvPr/>
         </p:nvSpPr>
@@ -4740,33 +7238,1116 @@
           </a:p>
         </p:txBody>
       </p:sp>
-      <p:pic>
-        <p:nvPicPr>
-          <p:cNvPr id="4" name="Image 0" descr="/Users/acandiatale/webWorkspace/migration-agent/docs/migration-agent/diagrams/flow-ladder.png">    </p:cNvPr>
-          <p:cNvPicPr>
-            <a:picLocks noChangeAspect="1"/>
-          </p:cNvPicPr>
-          <p:nvPr/>
-        </p:nvPicPr>
-        <p:blipFill>
-          <a:blip r:embed="rId1"/>
-          <a:stretch>
-            <a:fillRect/>
-          </a:stretch>
-        </p:blipFill>
-        <p:spPr>
-          <a:xfrm>
-            <a:off x="457200" y="1524622"/>
-            <a:ext cx="8229600" cy="1385596"/>
+      <p:sp>
+        <p:nvSpPr>
+          <p:cNvPr id="4" name="Text 1"/>
+          <p:cNvSpPr/>
+          <p:nvPr/>
+        </p:nvSpPr>
+        <p:spPr>
+          <a:xfrm>
+            <a:off x="457200" y="1920240"/>
+            <a:ext cx="1463040" cy="731520"/>
+          </a:xfrm>
+          <a:prstGeom prst="roundRect">
+            <a:avLst>
+              <a:gd name="adj" fmla="val 6250"/>
+            </a:avLst>
+          </a:prstGeom>
+          <a:solidFill>
+            <a:srgbClr val="FFFFFF"/>
+          </a:solidFill>
+          <a:ln w="12700">
+            <a:solidFill>
+              <a:srgbClr val="8A8F8A"/>
+            </a:solidFill>
+          </a:ln>
+        </p:spPr>
+        <p:txBody>
+          <a:bodyPr wrap="square" lIns="635" tIns="635" rIns="635" bIns="635" rtlCol="0" anchor="ctr"/>
+          <a:lstStyle/>
+          <a:p>
+            <a:pPr algn="ctr" indent="0" marL="0">
+              <a:spcAft>
+                <a:spcPts val="200"/>
+              </a:spcAft>
+              <a:buNone/>
+            </a:pPr>
+            <a:r>
+              <a:rPr lang="en-US" sz="1100" b="1" dirty="0">
+                <a:solidFill>
+                  <a:srgbClr val="1C2A1E"/>
+                </a:solidFill>
+                <a:latin typeface="Calibri" pitchFamily="34" charset="0"/>
+                <a:ea typeface="Calibri" pitchFamily="34" charset="-122"/>
+                <a:cs typeface="Calibri" pitchFamily="34" charset="-120"/>
+              </a:rPr>
+              <a:t>저장된 방법이 있나?</a:t>
+            </a:r>
+            <a:endParaRPr lang="en-US" sz="1100" dirty="0"/>
+          </a:p>
+          <a:p>
+            <a:pPr algn="ctr" indent="0" marL="0">
+              <a:spcAft>
+                <a:spcPts val="200"/>
+              </a:spcAft>
+              <a:buNone/>
+            </a:pPr>
+            <a:r>
+              <a:rPr lang="en-US" sz="850" dirty="0">
+                <a:solidFill>
+                  <a:srgbClr val="1C2A1E"/>
+                </a:solidFill>
+                <a:latin typeface="Calibri" pitchFamily="34" charset="0"/>
+                <a:ea typeface="Calibri" pitchFamily="34" charset="-122"/>
+                <a:cs typeface="Calibri" pitchFamily="34" charset="-120"/>
+              </a:rPr>
+              <a:t>지식베이스에서 같은 케이스를 찾습니다</a:t>
+            </a:r>
+            <a:endParaRPr lang="en-US" sz="1100" dirty="0"/>
+          </a:p>
+        </p:txBody>
+      </p:sp>
+      <p:sp>
+        <p:nvSpPr>
+          <p:cNvPr id="5" name="Text 2"/>
+          <p:cNvSpPr/>
+          <p:nvPr/>
+        </p:nvSpPr>
+        <p:spPr>
+          <a:xfrm>
+            <a:off x="2148840" y="1005840"/>
+            <a:ext cx="1463040" cy="731520"/>
+          </a:xfrm>
+          <a:prstGeom prst="roundRect">
+            <a:avLst>
+              <a:gd name="adj" fmla="val 6250"/>
+            </a:avLst>
+          </a:prstGeom>
+          <a:solidFill>
+            <a:srgbClr val="EEF3EA"/>
+          </a:solidFill>
+          <a:ln w="12700">
+            <a:solidFill>
+              <a:srgbClr val="2C5F2D"/>
+            </a:solidFill>
+          </a:ln>
+        </p:spPr>
+        <p:txBody>
+          <a:bodyPr wrap="square" lIns="635" tIns="635" rIns="635" bIns="635" rtlCol="0" anchor="ctr"/>
+          <a:lstStyle/>
+          <a:p>
+            <a:pPr algn="ctr" indent="0" marL="0">
+              <a:spcAft>
+                <a:spcPts val="200"/>
+              </a:spcAft>
+              <a:buNone/>
+            </a:pPr>
+            <a:r>
+              <a:rPr lang="en-US" sz="1100" b="1" dirty="0">
+                <a:solidFill>
+                  <a:srgbClr val="1C2A1E"/>
+                </a:solidFill>
+                <a:latin typeface="Calibri" pitchFamily="34" charset="0"/>
+                <a:ea typeface="Calibri" pitchFamily="34" charset="-122"/>
+                <a:cs typeface="Calibri" pitchFamily="34" charset="-120"/>
+              </a:rPr>
+              <a:t>저장된 방법 적용</a:t>
+            </a:r>
+            <a:endParaRPr lang="en-US" sz="1100" dirty="0"/>
+          </a:p>
+          <a:p>
+            <a:pPr algn="ctr" indent="0" marL="0">
+              <a:spcAft>
+                <a:spcPts val="200"/>
+              </a:spcAft>
+              <a:buNone/>
+            </a:pPr>
+            <a:r>
+              <a:rPr lang="en-US" sz="850" dirty="0">
+                <a:solidFill>
+                  <a:srgbClr val="1C2A1E"/>
+                </a:solidFill>
+                <a:latin typeface="Calibri" pitchFamily="34" charset="0"/>
+                <a:ea typeface="Calibri" pitchFamily="34" charset="-122"/>
+                <a:cs typeface="Calibri" pitchFamily="34" charset="-120"/>
+              </a:rPr>
+              <a:t>앞 프로젝트의 스크립트 그대로, LLM 없이</a:t>
+            </a:r>
+            <a:endParaRPr lang="en-US" sz="1100" dirty="0"/>
+          </a:p>
+        </p:txBody>
+      </p:sp>
+      <p:sp>
+        <p:nvSpPr>
+          <p:cNvPr id="6" name="Text 3"/>
+          <p:cNvSpPr/>
+          <p:nvPr/>
+        </p:nvSpPr>
+        <p:spPr>
+          <a:xfrm>
+            <a:off x="3840480" y="1005840"/>
+            <a:ext cx="1463040" cy="731520"/>
+          </a:xfrm>
+          <a:prstGeom prst="roundRect">
+            <a:avLst>
+              <a:gd name="adj" fmla="val 6250"/>
+            </a:avLst>
+          </a:prstGeom>
+          <a:solidFill>
+            <a:srgbClr val="2C5F2D"/>
+          </a:solidFill>
+          <a:ln w="12700">
+            <a:solidFill>
+              <a:srgbClr val="2C5F2D"/>
+            </a:solidFill>
+          </a:ln>
+        </p:spPr>
+        <p:txBody>
+          <a:bodyPr wrap="square" lIns="635" tIns="635" rIns="635" bIns="635" rtlCol="0" anchor="ctr"/>
+          <a:lstStyle/>
+          <a:p>
+            <a:pPr algn="ctr" indent="0" marL="0">
+              <a:spcAft>
+                <a:spcPts val="200"/>
+              </a:spcAft>
+              <a:buNone/>
+            </a:pPr>
+            <a:r>
+              <a:rPr lang="en-US" sz="1100" b="1" dirty="0">
+                <a:solidFill>
+                  <a:srgbClr val="FFFFFF"/>
+                </a:solidFill>
+                <a:latin typeface="Calibri" pitchFamily="34" charset="0"/>
+                <a:ea typeface="Calibri" pitchFamily="34" charset="-122"/>
+                <a:cs typeface="Calibri" pitchFamily="34" charset="-120"/>
+              </a:rPr>
+              <a:t>해결</a:t>
+            </a:r>
+            <a:endParaRPr lang="en-US" sz="1100" dirty="0"/>
+          </a:p>
+          <a:p>
+            <a:pPr algn="ctr" indent="0" marL="0">
+              <a:spcAft>
+                <a:spcPts val="200"/>
+              </a:spcAft>
+              <a:buNone/>
+            </a:pPr>
+            <a:r>
+              <a:rPr lang="en-US" sz="850" dirty="0">
+                <a:solidFill>
+                  <a:srgbClr val="FFFFFF"/>
+                </a:solidFill>
+                <a:latin typeface="Calibri" pitchFamily="34" charset="0"/>
+                <a:ea typeface="Calibri" pitchFamily="34" charset="-122"/>
+                <a:cs typeface="Calibri" pitchFamily="34" charset="-120"/>
+              </a:rPr>
+              <a:t>성공 횟수 +1</a:t>
+            </a:r>
+            <a:endParaRPr lang="en-US" sz="1100" dirty="0"/>
+          </a:p>
+        </p:txBody>
+      </p:sp>
+      <p:sp>
+        <p:nvSpPr>
+          <p:cNvPr id="7" name="Text 4"/>
+          <p:cNvSpPr/>
+          <p:nvPr/>
+        </p:nvSpPr>
+        <p:spPr>
+          <a:xfrm>
+            <a:off x="3840480" y="1920240"/>
+            <a:ext cx="1463040" cy="731520"/>
+          </a:xfrm>
+          <a:prstGeom prst="roundRect">
+            <a:avLst>
+              <a:gd name="adj" fmla="val 6250"/>
+            </a:avLst>
+          </a:prstGeom>
+          <a:solidFill>
+            <a:srgbClr val="3D5A80"/>
+          </a:solidFill>
+          <a:ln w="12700">
+            <a:solidFill>
+              <a:srgbClr val="3D5A80"/>
+            </a:solidFill>
+          </a:ln>
+        </p:spPr>
+        <p:txBody>
+          <a:bodyPr wrap="square" lIns="635" tIns="635" rIns="635" bIns="635" rtlCol="0" anchor="ctr"/>
+          <a:lstStyle/>
+          <a:p>
+            <a:pPr algn="ctr" indent="0" marL="0">
+              <a:spcAft>
+                <a:spcPts val="200"/>
+              </a:spcAft>
+              <a:buNone/>
+            </a:pPr>
+            <a:r>
+              <a:rPr lang="en-US" sz="1100" b="1" dirty="0">
+                <a:solidFill>
+                  <a:srgbClr val="FFFFFF"/>
+                </a:solidFill>
+                <a:latin typeface="Calibri" pitchFamily="34" charset="0"/>
+                <a:ea typeface="Calibri" pitchFamily="34" charset="-122"/>
+                <a:cs typeface="Calibri" pitchFamily="34" charset="-120"/>
+              </a:rPr>
+              <a:t>LLM 에게 요청</a:t>
+            </a:r>
+            <a:endParaRPr lang="en-US" sz="1100" dirty="0"/>
+          </a:p>
+          <a:p>
+            <a:pPr algn="ctr" indent="0" marL="0">
+              <a:spcAft>
+                <a:spcPts val="200"/>
+              </a:spcAft>
+              <a:buNone/>
+            </a:pPr>
+            <a:r>
+              <a:rPr lang="en-US" sz="850" dirty="0">
+                <a:solidFill>
+                  <a:srgbClr val="FFFFFF"/>
+                </a:solidFill>
+                <a:latin typeface="Calibri" pitchFamily="34" charset="0"/>
+                <a:ea typeface="Calibri" pitchFamily="34" charset="-122"/>
+                <a:cs typeface="Calibri" pitchFamily="34" charset="-120"/>
+              </a:rPr>
+              <a:t>오류·파일·pom·버전 정보, 실패 이유까지 줍니다</a:t>
+            </a:r>
+            <a:endParaRPr lang="en-US" sz="1100" dirty="0"/>
+          </a:p>
+        </p:txBody>
+      </p:sp>
+      <p:sp>
+        <p:nvSpPr>
+          <p:cNvPr id="8" name="Text 5"/>
+          <p:cNvSpPr/>
+          <p:nvPr/>
+        </p:nvSpPr>
+        <p:spPr>
+          <a:xfrm>
+            <a:off x="5532120" y="1920240"/>
+            <a:ext cx="1463040" cy="731520"/>
+          </a:xfrm>
+          <a:prstGeom prst="roundRect">
+            <a:avLst>
+              <a:gd name="adj" fmla="val 6250"/>
+            </a:avLst>
+          </a:prstGeom>
+          <a:solidFill>
+            <a:srgbClr val="FFFFFF"/>
+          </a:solidFill>
+          <a:ln w="12700">
+            <a:solidFill>
+              <a:srgbClr val="8A8F8A"/>
+            </a:solidFill>
+          </a:ln>
+        </p:spPr>
+        <p:txBody>
+          <a:bodyPr wrap="square" lIns="635" tIns="635" rIns="635" bIns="635" rtlCol="0" anchor="ctr"/>
+          <a:lstStyle/>
+          <a:p>
+            <a:pPr algn="ctr" indent="0" marL="0">
+              <a:spcAft>
+                <a:spcPts val="200"/>
+              </a:spcAft>
+              <a:buNone/>
+            </a:pPr>
+            <a:r>
+              <a:rPr lang="en-US" sz="1100" b="1" dirty="0">
+                <a:solidFill>
+                  <a:srgbClr val="1C2A1E"/>
+                </a:solidFill>
+                <a:latin typeface="Calibri" pitchFamily="34" charset="0"/>
+                <a:ea typeface="Calibri" pitchFamily="34" charset="-122"/>
+                <a:cs typeface="Calibri" pitchFamily="34" charset="-120"/>
+              </a:rPr>
+              <a:t>빌드로 확인</a:t>
+            </a:r>
+            <a:endParaRPr lang="en-US" sz="1100" dirty="0"/>
+          </a:p>
+          <a:p>
+            <a:pPr algn="ctr" indent="0" marL="0">
+              <a:spcAft>
+                <a:spcPts val="200"/>
+              </a:spcAft>
+              <a:buNone/>
+            </a:pPr>
+            <a:r>
+              <a:rPr lang="en-US" sz="850" dirty="0">
+                <a:solidFill>
+                  <a:srgbClr val="1C2A1E"/>
+                </a:solidFill>
+                <a:latin typeface="Calibri" pitchFamily="34" charset="0"/>
+                <a:ea typeface="Calibri" pitchFamily="34" charset="-122"/>
+                <a:cs typeface="Calibri" pitchFamily="34" charset="-120"/>
+              </a:rPr>
+              <a:t>고쳐졌나? 한 케이스에 최대 3번</a:t>
+            </a:r>
+            <a:endParaRPr lang="en-US" sz="1100" dirty="0"/>
+          </a:p>
+        </p:txBody>
+      </p:sp>
+      <p:sp>
+        <p:nvSpPr>
+          <p:cNvPr id="9" name="Text 6"/>
+          <p:cNvSpPr/>
+          <p:nvPr/>
+        </p:nvSpPr>
+        <p:spPr>
+          <a:xfrm>
+            <a:off x="7223760" y="1005840"/>
+            <a:ext cx="1463040" cy="731520"/>
+          </a:xfrm>
+          <a:prstGeom prst="roundRect">
+            <a:avLst>
+              <a:gd name="adj" fmla="val 6250"/>
+            </a:avLst>
+          </a:prstGeom>
+          <a:solidFill>
+            <a:srgbClr val="2C5F2D"/>
+          </a:solidFill>
+          <a:ln w="12700">
+            <a:solidFill>
+              <a:srgbClr val="2C5F2D"/>
+            </a:solidFill>
+          </a:ln>
+        </p:spPr>
+        <p:txBody>
+          <a:bodyPr wrap="square" lIns="635" tIns="635" rIns="635" bIns="635" rtlCol="0" anchor="ctr"/>
+          <a:lstStyle/>
+          <a:p>
+            <a:pPr algn="ctr" indent="0" marL="0">
+              <a:spcAft>
+                <a:spcPts val="200"/>
+              </a:spcAft>
+              <a:buNone/>
+            </a:pPr>
+            <a:r>
+              <a:rPr lang="en-US" sz="1100" b="1" dirty="0">
+                <a:solidFill>
+                  <a:srgbClr val="FFFFFF"/>
+                </a:solidFill>
+                <a:latin typeface="Calibri" pitchFamily="34" charset="0"/>
+                <a:ea typeface="Calibri" pitchFamily="34" charset="-122"/>
+                <a:cs typeface="Calibri" pitchFamily="34" charset="-120"/>
+              </a:rPr>
+              <a:t>해결하고 저장</a:t>
+            </a:r>
+            <a:endParaRPr lang="en-US" sz="1100" dirty="0"/>
+          </a:p>
+          <a:p>
+            <a:pPr algn="ctr" indent="0" marL="0">
+              <a:spcAft>
+                <a:spcPts val="200"/>
+              </a:spcAft>
+              <a:buNone/>
+            </a:pPr>
+            <a:r>
+              <a:rPr lang="en-US" sz="850" dirty="0">
+                <a:solidFill>
+                  <a:srgbClr val="FFFFFF"/>
+                </a:solidFill>
+                <a:latin typeface="Calibri" pitchFamily="34" charset="0"/>
+                <a:ea typeface="Calibri" pitchFamily="34" charset="-122"/>
+                <a:cs typeface="Calibri" pitchFamily="34" charset="-120"/>
+              </a:rPr>
+              <a:t>새 스크립트를 케이스 폴더에 저장</a:t>
+            </a:r>
+            <a:endParaRPr lang="en-US" sz="1100" dirty="0"/>
+          </a:p>
+        </p:txBody>
+      </p:sp>
+      <p:sp>
+        <p:nvSpPr>
+          <p:cNvPr id="10" name="Text 7"/>
+          <p:cNvSpPr/>
+          <p:nvPr/>
+        </p:nvSpPr>
+        <p:spPr>
+          <a:xfrm>
+            <a:off x="7223760" y="2834640"/>
+            <a:ext cx="1463040" cy="731520"/>
+          </a:xfrm>
+          <a:prstGeom prst="roundRect">
+            <a:avLst>
+              <a:gd name="adj" fmla="val 6250"/>
+            </a:avLst>
+          </a:prstGeom>
+          <a:solidFill>
+            <a:srgbClr val="E07A5F"/>
+          </a:solidFill>
+          <a:ln w="12700">
+            <a:solidFill>
+              <a:srgbClr val="E07A5F"/>
+            </a:solidFill>
+          </a:ln>
+        </p:spPr>
+        <p:txBody>
+          <a:bodyPr wrap="square" lIns="635" tIns="635" rIns="635" bIns="635" rtlCol="0" anchor="ctr"/>
+          <a:lstStyle/>
+          <a:p>
+            <a:pPr algn="ctr" indent="0" marL="0">
+              <a:spcAft>
+                <a:spcPts val="200"/>
+              </a:spcAft>
+              <a:buNone/>
+            </a:pPr>
+            <a:r>
+              <a:rPr lang="en-US" sz="1100" b="1" dirty="0">
+                <a:solidFill>
+                  <a:srgbClr val="FFFFFF"/>
+                </a:solidFill>
+                <a:latin typeface="Calibri" pitchFamily="34" charset="0"/>
+                <a:ea typeface="Calibri" pitchFamily="34" charset="-122"/>
+                <a:cs typeface="Calibri" pitchFamily="34" charset="-120"/>
+              </a:rPr>
+              <a:t>사람에게 인계</a:t>
+            </a:r>
+            <a:endParaRPr lang="en-US" sz="1100" dirty="0"/>
+          </a:p>
+          <a:p>
+            <a:pPr algn="ctr" indent="0" marL="0">
+              <a:spcAft>
+                <a:spcPts val="200"/>
+              </a:spcAft>
+              <a:buNone/>
+            </a:pPr>
+            <a:r>
+              <a:rPr lang="en-US" sz="850" dirty="0">
+                <a:solidFill>
+                  <a:srgbClr val="FFFFFF"/>
+                </a:solidFill>
+                <a:latin typeface="Calibri" pitchFamily="34" charset="0"/>
+                <a:ea typeface="Calibri" pitchFamily="34" charset="-122"/>
+                <a:cs typeface="Calibri" pitchFamily="34" charset="-120"/>
+              </a:rPr>
+              <a:t>보고서 맨 앞에 적어 넘깁니다</a:t>
+            </a:r>
+            <a:endParaRPr lang="en-US" sz="1100" dirty="0"/>
+          </a:p>
+        </p:txBody>
+      </p:sp>
+      <p:sp>
+        <p:nvSpPr>
+          <p:cNvPr id="11" name="Shape 8"/>
+          <p:cNvSpPr/>
+          <p:nvPr/>
+        </p:nvSpPr>
+        <p:spPr>
+          <a:xfrm flipV="1">
+            <a:off x="1188720" y="1371600"/>
+            <a:ext cx="0" cy="548640"/>
+          </a:xfrm>
+          <a:prstGeom prst="line">
+            <a:avLst/>
+          </a:prstGeom>
+          <a:noFill/>
+          <a:ln w="15875">
+            <a:solidFill>
+              <a:srgbClr val="4A4F4A"/>
+            </a:solidFill>
+            <a:prstDash val="solid"/>
+          </a:ln>
+        </p:spPr>
+      </p:sp>
+      <p:sp>
+        <p:nvSpPr>
+          <p:cNvPr id="12" name="Shape 9"/>
+          <p:cNvSpPr/>
+          <p:nvPr/>
+        </p:nvSpPr>
+        <p:spPr>
+          <a:xfrm>
+            <a:off x="1188720" y="1371600"/>
+            <a:ext cx="960120" cy="0"/>
+          </a:xfrm>
+          <a:prstGeom prst="line">
+            <a:avLst/>
+          </a:prstGeom>
+          <a:noFill/>
+          <a:ln w="15875">
+            <a:solidFill>
+              <a:srgbClr val="4A4F4A"/>
+            </a:solidFill>
+            <a:prstDash val="solid"/>
+            <a:tailEnd type="triangle"/>
+          </a:ln>
+        </p:spPr>
+      </p:sp>
+      <p:sp>
+        <p:nvSpPr>
+          <p:cNvPr id="13" name="Text 10"/>
+          <p:cNvSpPr txBox="1"/>
+          <p:nvPr/>
+        </p:nvSpPr>
+        <p:spPr>
+          <a:xfrm>
+            <a:off x="1303020" y="1545336"/>
+            <a:ext cx="411480" cy="201168"/>
           </a:xfrm>
           <a:prstGeom prst="rect">
             <a:avLst/>
           </a:prstGeom>
-        </p:spPr>
-      </p:pic>
-      <p:sp>
-        <p:nvSpPr>
-          <p:cNvPr id="5" name="Text 1"/>
+          <a:solidFill>
+            <a:srgbClr val="FFFFFF"/>
+          </a:solidFill>
+          <a:ln/>
+        </p:spPr>
+        <p:txBody>
+          <a:bodyPr wrap="square" lIns="0" tIns="0" rIns="0" bIns="0" rtlCol="0" anchor="ctr"/>
+          <a:lstStyle/>
+          <a:p>
+            <a:pPr algn="ctr" indent="0" marL="0">
+              <a:buNone/>
+            </a:pPr>
+            <a:r>
+              <a:rPr lang="en-US" sz="850" dirty="0">
+                <a:solidFill>
+                  <a:srgbClr val="4A4F4A"/>
+                </a:solidFill>
+                <a:latin typeface="Calibri" pitchFamily="34" charset="0"/>
+                <a:ea typeface="Calibri" pitchFamily="34" charset="-122"/>
+                <a:cs typeface="Calibri" pitchFamily="34" charset="-120"/>
+              </a:rPr>
+              <a:t>있음</a:t>
+            </a:r>
+            <a:endParaRPr lang="en-US" sz="850" dirty="0"/>
+          </a:p>
+        </p:txBody>
+      </p:sp>
+      <p:sp>
+        <p:nvSpPr>
+          <p:cNvPr id="14" name="Shape 11"/>
+          <p:cNvSpPr/>
+          <p:nvPr/>
+        </p:nvSpPr>
+        <p:spPr>
+          <a:xfrm>
+            <a:off x="1920240" y="2286000"/>
+            <a:ext cx="1920240" cy="0"/>
+          </a:xfrm>
+          <a:prstGeom prst="line">
+            <a:avLst/>
+          </a:prstGeom>
+          <a:noFill/>
+          <a:ln w="15875">
+            <a:solidFill>
+              <a:srgbClr val="4A4F4A"/>
+            </a:solidFill>
+            <a:prstDash val="solid"/>
+            <a:tailEnd type="triangle"/>
+          </a:ln>
+        </p:spPr>
+      </p:sp>
+      <p:sp>
+        <p:nvSpPr>
+          <p:cNvPr id="15" name="Text 12"/>
+          <p:cNvSpPr txBox="1"/>
+          <p:nvPr/>
+        </p:nvSpPr>
+        <p:spPr>
+          <a:xfrm>
+            <a:off x="2674620" y="2386584"/>
+            <a:ext cx="411480" cy="201168"/>
+          </a:xfrm>
+          <a:prstGeom prst="rect">
+            <a:avLst/>
+          </a:prstGeom>
+          <a:solidFill>
+            <a:srgbClr val="FFFFFF"/>
+          </a:solidFill>
+          <a:ln/>
+        </p:spPr>
+        <p:txBody>
+          <a:bodyPr wrap="square" lIns="0" tIns="0" rIns="0" bIns="0" rtlCol="0" anchor="ctr"/>
+          <a:lstStyle/>
+          <a:p>
+            <a:pPr algn="ctr" indent="0" marL="0">
+              <a:buNone/>
+            </a:pPr>
+            <a:r>
+              <a:rPr lang="en-US" sz="850" dirty="0">
+                <a:solidFill>
+                  <a:srgbClr val="4A4F4A"/>
+                </a:solidFill>
+                <a:latin typeface="Calibri" pitchFamily="34" charset="0"/>
+                <a:ea typeface="Calibri" pitchFamily="34" charset="-122"/>
+                <a:cs typeface="Calibri" pitchFamily="34" charset="-120"/>
+              </a:rPr>
+              <a:t>없음</a:t>
+            </a:r>
+            <a:endParaRPr lang="en-US" sz="850" dirty="0"/>
+          </a:p>
+        </p:txBody>
+      </p:sp>
+      <p:sp>
+        <p:nvSpPr>
+          <p:cNvPr id="16" name="Shape 13"/>
+          <p:cNvSpPr/>
+          <p:nvPr/>
+        </p:nvSpPr>
+        <p:spPr>
+          <a:xfrm>
+            <a:off x="3611880" y="1371600"/>
+            <a:ext cx="228600" cy="0"/>
+          </a:xfrm>
+          <a:prstGeom prst="line">
+            <a:avLst/>
+          </a:prstGeom>
+          <a:noFill/>
+          <a:ln w="15875">
+            <a:solidFill>
+              <a:srgbClr val="4A4F4A"/>
+            </a:solidFill>
+            <a:prstDash val="solid"/>
+            <a:tailEnd type="triangle"/>
+          </a:ln>
+        </p:spPr>
+      </p:sp>
+      <p:sp>
+        <p:nvSpPr>
+          <p:cNvPr id="17" name="Text 14"/>
+          <p:cNvSpPr txBox="1"/>
+          <p:nvPr/>
+        </p:nvSpPr>
+        <p:spPr>
+          <a:xfrm>
+            <a:off x="3474720" y="1088136"/>
+            <a:ext cx="502920" cy="201168"/>
+          </a:xfrm>
+          <a:prstGeom prst="rect">
+            <a:avLst/>
+          </a:prstGeom>
+          <a:solidFill>
+            <a:srgbClr val="FFFFFF"/>
+          </a:solidFill>
+          <a:ln/>
+        </p:spPr>
+        <p:txBody>
+          <a:bodyPr wrap="square" lIns="0" tIns="0" rIns="0" bIns="0" rtlCol="0" anchor="ctr"/>
+          <a:lstStyle/>
+          <a:p>
+            <a:pPr algn="ctr" indent="0" marL="0">
+              <a:buNone/>
+            </a:pPr>
+            <a:r>
+              <a:rPr lang="en-US" sz="850" dirty="0">
+                <a:solidFill>
+                  <a:srgbClr val="4A4F4A"/>
+                </a:solidFill>
+                <a:latin typeface="Calibri" pitchFamily="34" charset="0"/>
+                <a:ea typeface="Calibri" pitchFamily="34" charset="-122"/>
+                <a:cs typeface="Calibri" pitchFamily="34" charset="-120"/>
+              </a:rPr>
+              <a:t>고쳐짐</a:t>
+            </a:r>
+            <a:endParaRPr lang="en-US" sz="850" dirty="0"/>
+          </a:p>
+        </p:txBody>
+      </p:sp>
+      <p:sp>
+        <p:nvSpPr>
+          <p:cNvPr id="18" name="Shape 15"/>
+          <p:cNvSpPr/>
+          <p:nvPr/>
+        </p:nvSpPr>
+        <p:spPr>
+          <a:xfrm>
+            <a:off x="2880360" y="1737360"/>
+            <a:ext cx="0" cy="365760"/>
+          </a:xfrm>
+          <a:prstGeom prst="line">
+            <a:avLst/>
+          </a:prstGeom>
+          <a:noFill/>
+          <a:ln w="15875">
+            <a:solidFill>
+              <a:srgbClr val="4A4F4A"/>
+            </a:solidFill>
+            <a:prstDash val="solid"/>
+          </a:ln>
+        </p:spPr>
+      </p:sp>
+      <p:sp>
+        <p:nvSpPr>
+          <p:cNvPr id="19" name="Shape 16"/>
+          <p:cNvSpPr/>
+          <p:nvPr/>
+        </p:nvSpPr>
+        <p:spPr>
+          <a:xfrm>
+            <a:off x="2880360" y="2103120"/>
+            <a:ext cx="960120" cy="0"/>
+          </a:xfrm>
+          <a:prstGeom prst="line">
+            <a:avLst/>
+          </a:prstGeom>
+          <a:noFill/>
+          <a:ln w="15875">
+            <a:solidFill>
+              <a:srgbClr val="4A4F4A"/>
+            </a:solidFill>
+            <a:prstDash val="solid"/>
+            <a:tailEnd type="triangle"/>
+          </a:ln>
+        </p:spPr>
+      </p:sp>
+      <p:sp>
+        <p:nvSpPr>
+          <p:cNvPr id="20" name="Text 17"/>
+          <p:cNvSpPr txBox="1"/>
+          <p:nvPr/>
+        </p:nvSpPr>
+        <p:spPr>
+          <a:xfrm>
+            <a:off x="2971800" y="1911096"/>
+            <a:ext cx="548640" cy="201168"/>
+          </a:xfrm>
+          <a:prstGeom prst="rect">
+            <a:avLst/>
+          </a:prstGeom>
+          <a:solidFill>
+            <a:srgbClr val="FFFFFF"/>
+          </a:solidFill>
+          <a:ln/>
+        </p:spPr>
+        <p:txBody>
+          <a:bodyPr wrap="square" lIns="0" tIns="0" rIns="0" bIns="0" rtlCol="0" anchor="ctr"/>
+          <a:lstStyle/>
+          <a:p>
+            <a:pPr algn="ctr" indent="0" marL="0">
+              <a:buNone/>
+            </a:pPr>
+            <a:r>
+              <a:rPr lang="en-US" sz="850" dirty="0">
+                <a:solidFill>
+                  <a:srgbClr val="4A4F4A"/>
+                </a:solidFill>
+                <a:latin typeface="Calibri" pitchFamily="34" charset="0"/>
+                <a:ea typeface="Calibri" pitchFamily="34" charset="-122"/>
+                <a:cs typeface="Calibri" pitchFamily="34" charset="-120"/>
+              </a:rPr>
+              <a:t>안 통함</a:t>
+            </a:r>
+            <a:endParaRPr lang="en-US" sz="850" dirty="0"/>
+          </a:p>
+        </p:txBody>
+      </p:sp>
+      <p:sp>
+        <p:nvSpPr>
+          <p:cNvPr id="21" name="Shape 18"/>
+          <p:cNvSpPr/>
+          <p:nvPr/>
+        </p:nvSpPr>
+        <p:spPr>
+          <a:xfrm>
+            <a:off x="5303520" y="2286000"/>
+            <a:ext cx="228600" cy="0"/>
+          </a:xfrm>
+          <a:prstGeom prst="line">
+            <a:avLst/>
+          </a:prstGeom>
+          <a:noFill/>
+          <a:ln w="15875">
+            <a:solidFill>
+              <a:srgbClr val="4A4F4A"/>
+            </a:solidFill>
+            <a:prstDash val="solid"/>
+            <a:tailEnd type="triangle"/>
+          </a:ln>
+        </p:spPr>
+      </p:sp>
+      <p:sp>
+        <p:nvSpPr>
+          <p:cNvPr id="22" name="Shape 19"/>
+          <p:cNvSpPr/>
+          <p:nvPr/>
+        </p:nvSpPr>
+        <p:spPr>
+          <a:xfrm flipV="1">
+            <a:off x="6263640" y="1371600"/>
+            <a:ext cx="0" cy="548640"/>
+          </a:xfrm>
+          <a:prstGeom prst="line">
+            <a:avLst/>
+          </a:prstGeom>
+          <a:noFill/>
+          <a:ln w="15875">
+            <a:solidFill>
+              <a:srgbClr val="4A4F4A"/>
+            </a:solidFill>
+            <a:prstDash val="solid"/>
+          </a:ln>
+        </p:spPr>
+      </p:sp>
+      <p:sp>
+        <p:nvSpPr>
+          <p:cNvPr id="23" name="Shape 20"/>
+          <p:cNvSpPr/>
+          <p:nvPr/>
+        </p:nvSpPr>
+        <p:spPr>
+          <a:xfrm>
+            <a:off x="6263640" y="1371600"/>
+            <a:ext cx="960120" cy="0"/>
+          </a:xfrm>
+          <a:prstGeom prst="line">
+            <a:avLst/>
+          </a:prstGeom>
+          <a:noFill/>
+          <a:ln w="15875">
+            <a:solidFill>
+              <a:srgbClr val="4A4F4A"/>
+            </a:solidFill>
+            <a:prstDash val="solid"/>
+            <a:tailEnd type="triangle"/>
+          </a:ln>
+        </p:spPr>
+      </p:sp>
+      <p:sp>
+        <p:nvSpPr>
+          <p:cNvPr id="24" name="Text 21"/>
+          <p:cNvSpPr txBox="1"/>
+          <p:nvPr/>
+        </p:nvSpPr>
+        <p:spPr>
+          <a:xfrm>
+            <a:off x="6377940" y="1545336"/>
+            <a:ext cx="502920" cy="201168"/>
+          </a:xfrm>
+          <a:prstGeom prst="rect">
+            <a:avLst/>
+          </a:prstGeom>
+          <a:solidFill>
+            <a:srgbClr val="FFFFFF"/>
+          </a:solidFill>
+          <a:ln/>
+        </p:spPr>
+        <p:txBody>
+          <a:bodyPr wrap="square" lIns="0" tIns="0" rIns="0" bIns="0" rtlCol="0" anchor="ctr"/>
+          <a:lstStyle/>
+          <a:p>
+            <a:pPr algn="ctr" indent="0" marL="0">
+              <a:buNone/>
+            </a:pPr>
+            <a:r>
+              <a:rPr lang="en-US" sz="850" dirty="0">
+                <a:solidFill>
+                  <a:srgbClr val="4A4F4A"/>
+                </a:solidFill>
+                <a:latin typeface="Calibri" pitchFamily="34" charset="0"/>
+                <a:ea typeface="Calibri" pitchFamily="34" charset="-122"/>
+                <a:cs typeface="Calibri" pitchFamily="34" charset="-120"/>
+              </a:rPr>
+              <a:t>고쳐짐</a:t>
+            </a:r>
+            <a:endParaRPr lang="en-US" sz="850" dirty="0"/>
+          </a:p>
+        </p:txBody>
+      </p:sp>
+      <p:sp>
+        <p:nvSpPr>
+          <p:cNvPr id="25" name="Shape 22"/>
+          <p:cNvSpPr/>
+          <p:nvPr/>
+        </p:nvSpPr>
+        <p:spPr>
+          <a:xfrm>
+            <a:off x="6263640" y="2651760"/>
+            <a:ext cx="0" cy="548640"/>
+          </a:xfrm>
+          <a:prstGeom prst="line">
+            <a:avLst/>
+          </a:prstGeom>
+          <a:noFill/>
+          <a:ln w="15875">
+            <a:solidFill>
+              <a:srgbClr val="4A4F4A"/>
+            </a:solidFill>
+            <a:prstDash val="solid"/>
+          </a:ln>
+        </p:spPr>
+      </p:sp>
+      <p:sp>
+        <p:nvSpPr>
+          <p:cNvPr id="26" name="Shape 23"/>
+          <p:cNvSpPr/>
+          <p:nvPr/>
+        </p:nvSpPr>
+        <p:spPr>
+          <a:xfrm>
+            <a:off x="6263640" y="3200400"/>
+            <a:ext cx="960120" cy="0"/>
+          </a:xfrm>
+          <a:prstGeom prst="line">
+            <a:avLst/>
+          </a:prstGeom>
+          <a:noFill/>
+          <a:ln w="15875">
+            <a:solidFill>
+              <a:srgbClr val="4A4F4A"/>
+            </a:solidFill>
+            <a:prstDash val="solid"/>
+            <a:tailEnd type="triangle"/>
+          </a:ln>
+        </p:spPr>
+      </p:sp>
+      <p:sp>
+        <p:nvSpPr>
+          <p:cNvPr id="27" name="Text 24"/>
+          <p:cNvSpPr txBox="1"/>
+          <p:nvPr/>
+        </p:nvSpPr>
+        <p:spPr>
+          <a:xfrm>
+            <a:off x="6377940" y="2825496"/>
+            <a:ext cx="594360" cy="201168"/>
+          </a:xfrm>
+          <a:prstGeom prst="rect">
+            <a:avLst/>
+          </a:prstGeom>
+          <a:solidFill>
+            <a:srgbClr val="FFFFFF"/>
+          </a:solidFill>
+          <a:ln/>
+        </p:spPr>
+        <p:txBody>
+          <a:bodyPr wrap="square" lIns="0" tIns="0" rIns="0" bIns="0" rtlCol="0" anchor="ctr"/>
+          <a:lstStyle/>
+          <a:p>
+            <a:pPr algn="ctr" indent="0" marL="0">
+              <a:buNone/>
+            </a:pPr>
+            <a:r>
+              <a:rPr lang="en-US" sz="850" dirty="0">
+                <a:solidFill>
+                  <a:srgbClr val="4A4F4A"/>
+                </a:solidFill>
+                <a:latin typeface="Calibri" pitchFamily="34" charset="0"/>
+                <a:ea typeface="Calibri" pitchFamily="34" charset="-122"/>
+                <a:cs typeface="Calibri" pitchFamily="34" charset="-120"/>
+              </a:rPr>
+              <a:t>3번 실패</a:t>
+            </a:r>
+            <a:endParaRPr lang="en-US" sz="850" dirty="0"/>
+          </a:p>
+        </p:txBody>
+      </p:sp>
+      <p:sp>
+        <p:nvSpPr>
+          <p:cNvPr id="28" name="Shape 25"/>
+          <p:cNvSpPr/>
+          <p:nvPr/>
+        </p:nvSpPr>
+        <p:spPr>
+          <a:xfrm>
+            <a:off x="5806440" y="2651760"/>
+            <a:ext cx="0" cy="274320"/>
+          </a:xfrm>
+          <a:prstGeom prst="line">
+            <a:avLst/>
+          </a:prstGeom>
+          <a:noFill/>
+          <a:ln w="15875">
+            <a:solidFill>
+              <a:srgbClr val="4A4F4A"/>
+            </a:solidFill>
+            <a:prstDash val="solid"/>
+          </a:ln>
+        </p:spPr>
+      </p:sp>
+      <p:sp>
+        <p:nvSpPr>
+          <p:cNvPr id="29" name="Shape 26"/>
+          <p:cNvSpPr/>
+          <p:nvPr/>
+        </p:nvSpPr>
+        <p:spPr>
+          <a:xfrm flipH="1">
+            <a:off x="4572000" y="2926080"/>
+            <a:ext cx="1234440" cy="0"/>
+          </a:xfrm>
+          <a:prstGeom prst="line">
+            <a:avLst/>
+          </a:prstGeom>
+          <a:noFill/>
+          <a:ln w="15875">
+            <a:solidFill>
+              <a:srgbClr val="4A4F4A"/>
+            </a:solidFill>
+            <a:prstDash val="solid"/>
+          </a:ln>
+        </p:spPr>
+      </p:sp>
+      <p:sp>
+        <p:nvSpPr>
+          <p:cNvPr id="30" name="Shape 27"/>
+          <p:cNvSpPr/>
+          <p:nvPr/>
+        </p:nvSpPr>
+        <p:spPr>
+          <a:xfrm flipV="1">
+            <a:off x="4572000" y="2651760"/>
+            <a:ext cx="0" cy="274320"/>
+          </a:xfrm>
+          <a:prstGeom prst="line">
+            <a:avLst/>
+          </a:prstGeom>
+          <a:noFill/>
+          <a:ln w="15875">
+            <a:solidFill>
+              <a:srgbClr val="4A4F4A"/>
+            </a:solidFill>
+            <a:prstDash val="solid"/>
+            <a:tailEnd type="triangle"/>
+          </a:ln>
+        </p:spPr>
+      </p:sp>
+      <p:sp>
+        <p:nvSpPr>
+          <p:cNvPr id="31" name="Text 28"/>
+          <p:cNvSpPr txBox="1"/>
+          <p:nvPr/>
+        </p:nvSpPr>
+        <p:spPr>
+          <a:xfrm>
+            <a:off x="5006340" y="2825496"/>
+            <a:ext cx="365760" cy="201168"/>
+          </a:xfrm>
+          <a:prstGeom prst="rect">
+            <a:avLst/>
+          </a:prstGeom>
+          <a:solidFill>
+            <a:srgbClr val="FFFFFF"/>
+          </a:solidFill>
+          <a:ln/>
+        </p:spPr>
+        <p:txBody>
+          <a:bodyPr wrap="square" lIns="0" tIns="0" rIns="0" bIns="0" rtlCol="0" anchor="ctr"/>
+          <a:lstStyle/>
+          <a:p>
+            <a:pPr algn="ctr" indent="0" marL="0">
+              <a:buNone/>
+            </a:pPr>
+            <a:r>
+              <a:rPr lang="en-US" sz="850" dirty="0">
+                <a:solidFill>
+                  <a:srgbClr val="4A4F4A"/>
+                </a:solidFill>
+                <a:latin typeface="Calibri" pitchFamily="34" charset="0"/>
+                <a:ea typeface="Calibri" pitchFamily="34" charset="-122"/>
+                <a:cs typeface="Calibri" pitchFamily="34" charset="-120"/>
+              </a:rPr>
+              <a:t>다시</a:t>
+            </a:r>
+            <a:endParaRPr lang="en-US" sz="850" dirty="0"/>
+          </a:p>
+        </p:txBody>
+      </p:sp>
+      <p:sp>
+        <p:nvSpPr>
+          <p:cNvPr id="32" name="Text 29"/>
           <p:cNvSpPr txBox="1"/>
           <p:nvPr/>
         </p:nvSpPr>

</xml_diff>

<commit_message>
v2.1j: Ant projects — a tree with build.xml and no pom.xml gets a pom.xml synthesized at intake (sbmig/analyze/ant.py: layout from build.xml properties / javac / war tasks and the directories, jar coordinates from the jar's pom.properties → jar_names.yml + <kb>/jar_names.yml → sha1 Nexus 3 / Central lookup, provided container APIs, unknown-but-used jars declared system-scope at their as-is path from the top-level pom directory, unused ones left out, untranslatable targets noted), committed `intake: pom.xml synthesized from build.xml`, then the normal flow; flags pom-synthesized / jar-coordinates-unknown, Handover block with install-file commands, intake.* config; e2e fixture ant-webapp passes on real Maven; CLAUDE.md / RUNBOOK / KB-AND-FLOW / deck wording; trees with neither pom nor build.xml stay rejected
Co-Authored-By: Claude Fable 5.1 <noreply@anthropic.com>
Claude-Session: https://claude.ai/code/session_01DA5cmByyXTZsJjuyUviAya
</commit_message>
<xml_diff>
--- a/docs/migration-agent/migration-agent.pptx
+++ b/docs/migration-agent/migration-agent.pptx
@@ -116,7 +116,7 @@
   <p:extLst>
     <p:ext uri="{521415D9-36F7-43E2-AB2F-B90AF26B5E84}">
       <p14:sectionLst xmlns:p14="http://schemas.microsoft.com/office/powerpoint/2010/main">
-        <p14:section name="흐름" id="{71c8b9cf-434f-c343-2bb9-4e7cc2fc1095}">
+        <p14:section name="흐름" id="{61eec5ef-2698-063e-4c12-d8d19aed57f8}">
           <p14:sldIdLst>
             <p14:sldId id="256"/>
             <p14:sldId id="257"/>
@@ -2947,7 +2947,7 @@
                 <a:ea typeface="Calibri" pitchFamily="34" charset="-122"/>
                 <a:cs typeface="Calibri" pitchFamily="34" charset="-120"/>
               </a:rPr>
-              <a:t>Maven 프로젝트인지 확인하고 작업용 사본을 만듭니다</a:t>
+              <a:t>작업용 사본을 만듭니다. Ant 프로젝트면 pom.xml 을 만들어 받습니다</a:t>
             </a:r>
             <a:endParaRPr lang="en-US" sz="1100" dirty="0"/>
           </a:p>
@@ -4690,7 +4690,7 @@
                   <a:schemeClr val="tx1"/>
                 </a:solidFill>
               </a:rPr>
-              <a:t>프로젝트 폴더나 zip 을 받으면 먼저 Maven 프로젝트인지 봅니다. Gradle 이거나 pom.xml 없이 소스만 있는 폴더는 받지 않고, 이유를 적어 돌려줍니다.</a:t>
+              <a:t>프로젝트 폴더나 zip 을 받으면 먼저 빌드 방식을 봅니다. Maven 은 그대로, Ant(build.xml)는 pom.xml 을 만들어 받습니다. Gradle 이거나 빌드 파일 없이 소스만 있는 폴더는 받지 않고 이유를 적어 돌려줍니다.</a:t>
             </a:r>
             <a:endParaRPr lang="en-US" sz="1150" dirty="0"/>
           </a:p>

</xml_diff>